<commit_message>
chore: update "平均数" PowerPoint presentation file
</commit_message>
<xml_diff>
--- a/《平均数》.pptx
+++ b/《平均数》.pptx
@@ -222,7 +222,7 @@
           <a:p>
             <a:fld id="{D2A48B96-639E-45A3-A0BA-2464DFDB1FAA}" type="datetimeFigureOut">
               <a:rPr lang="zh-CN" altLang="en-US" smtClean="0"/>
-              <a:t>2026/4/2</a:t>
+              <a:t>2026/4/6</a:t>
             </a:fld>
             <a:endParaRPr lang="zh-CN" altLang="en-US"/>
           </a:p>
@@ -613,7 +613,7 @@
           <a:p>
             <a:fld id="{115465E4-B37B-4A4B-A30F-C966582A971F}" type="datetimeFigureOut">
               <a:rPr lang="zh-CN" altLang="en-US" smtClean="0"/>
-              <a:t>2026/4/2</a:t>
+              <a:t>2026/4/6</a:t>
             </a:fld>
             <a:endParaRPr lang="zh-CN" altLang="en-US"/>
           </a:p>
@@ -776,7 +776,7 @@
           <a:p>
             <a:fld id="{115465E4-B37B-4A4B-A30F-C966582A971F}" type="datetimeFigureOut">
               <a:rPr lang="zh-CN" altLang="en-US" smtClean="0"/>
-              <a:t>2026/4/2</a:t>
+              <a:t>2026/4/6</a:t>
             </a:fld>
             <a:endParaRPr lang="zh-CN" altLang="en-US"/>
           </a:p>
@@ -949,7 +949,7 @@
           <a:p>
             <a:fld id="{115465E4-B37B-4A4B-A30F-C966582A971F}" type="datetimeFigureOut">
               <a:rPr lang="zh-CN" altLang="en-US" smtClean="0"/>
-              <a:t>2026/4/2</a:t>
+              <a:t>2026/4/6</a:t>
             </a:fld>
             <a:endParaRPr lang="zh-CN" altLang="en-US"/>
           </a:p>
@@ -1112,7 +1112,7 @@
           <a:p>
             <a:fld id="{115465E4-B37B-4A4B-A30F-C966582A971F}" type="datetimeFigureOut">
               <a:rPr lang="zh-CN" altLang="en-US" smtClean="0"/>
-              <a:t>2026/4/2</a:t>
+              <a:t>2026/4/6</a:t>
             </a:fld>
             <a:endParaRPr lang="zh-CN" altLang="en-US"/>
           </a:p>
@@ -1352,7 +1352,7 @@
           <a:p>
             <a:fld id="{115465E4-B37B-4A4B-A30F-C966582A971F}" type="datetimeFigureOut">
               <a:rPr lang="zh-CN" altLang="en-US" smtClean="0"/>
-              <a:t>2026/4/2</a:t>
+              <a:t>2026/4/6</a:t>
             </a:fld>
             <a:endParaRPr lang="zh-CN" altLang="en-US"/>
           </a:p>
@@ -1576,7 +1576,7 @@
           <a:p>
             <a:fld id="{115465E4-B37B-4A4B-A30F-C966582A971F}" type="datetimeFigureOut">
               <a:rPr lang="zh-CN" altLang="en-US" smtClean="0"/>
-              <a:t>2026/4/2</a:t>
+              <a:t>2026/4/6</a:t>
             </a:fld>
             <a:endParaRPr lang="zh-CN" altLang="en-US"/>
           </a:p>
@@ -1935,7 +1935,7 @@
           <a:p>
             <a:fld id="{115465E4-B37B-4A4B-A30F-C966582A971F}" type="datetimeFigureOut">
               <a:rPr lang="zh-CN" altLang="en-US" smtClean="0"/>
-              <a:t>2026/4/2</a:t>
+              <a:t>2026/4/6</a:t>
             </a:fld>
             <a:endParaRPr lang="zh-CN" altLang="en-US"/>
           </a:p>
@@ -2047,7 +2047,7 @@
           <a:p>
             <a:fld id="{115465E4-B37B-4A4B-A30F-C966582A971F}" type="datetimeFigureOut">
               <a:rPr lang="zh-CN" altLang="en-US" smtClean="0"/>
-              <a:t>2026/4/2</a:t>
+              <a:t>2026/4/6</a:t>
             </a:fld>
             <a:endParaRPr lang="zh-CN" altLang="en-US"/>
           </a:p>
@@ -2137,7 +2137,7 @@
           <a:p>
             <a:fld id="{115465E4-B37B-4A4B-A30F-C966582A971F}" type="datetimeFigureOut">
               <a:rPr lang="zh-CN" altLang="en-US" smtClean="0"/>
-              <a:t>2026/4/2</a:t>
+              <a:t>2026/4/6</a:t>
             </a:fld>
             <a:endParaRPr lang="zh-CN" altLang="en-US"/>
           </a:p>
@@ -2407,7 +2407,7 @@
           <a:p>
             <a:fld id="{115465E4-B37B-4A4B-A30F-C966582A971F}" type="datetimeFigureOut">
               <a:rPr lang="zh-CN" altLang="en-US" smtClean="0"/>
-              <a:t>2026/4/2</a:t>
+              <a:t>2026/4/6</a:t>
             </a:fld>
             <a:endParaRPr lang="zh-CN" altLang="en-US"/>
           </a:p>
@@ -2654,7 +2654,7 @@
           <a:p>
             <a:fld id="{115465E4-B37B-4A4B-A30F-C966582A971F}" type="datetimeFigureOut">
               <a:rPr lang="zh-CN" altLang="en-US" smtClean="0"/>
-              <a:t>2026/4/2</a:t>
+              <a:t>2026/4/6</a:t>
             </a:fld>
             <a:endParaRPr lang="zh-CN" altLang="en-US"/>
           </a:p>
@@ -2866,7 +2866,7 @@
           <a:p>
             <a:fld id="{115465E4-B37B-4A4B-A30F-C966582A971F}" type="datetimeFigureOut">
               <a:rPr lang="zh-CN" altLang="en-US" smtClean="0"/>
-              <a:t>2026/4/2</a:t>
+              <a:t>2026/4/6</a:t>
             </a:fld>
             <a:endParaRPr lang="zh-CN" altLang="en-US"/>
           </a:p>
@@ -6926,7 +6926,7 @@
                         <a:buNone/>
                       </a:pPr>
                       <a:r>
-                        <a:rPr lang="zh-CN" altLang="en-US" sz="1200" b="0" i="0" u="none" strike="noStrike">
+                        <a:rPr lang="zh-CN" altLang="en-US" sz="1200" b="0" i="0" u="none" strike="noStrike" dirty="0">
                           <a:solidFill>
                             <a:srgbClr val="000000"/>
                           </a:solidFill>
@@ -7292,7 +7292,7 @@
                         <a:buNone/>
                       </a:pPr>
                       <a:r>
-                        <a:rPr lang="zh-CN" altLang="en-US" sz="1200" b="0" i="0" u="none" strike="noStrike">
+                        <a:rPr lang="zh-CN" altLang="en-US" sz="1200" b="0" i="0" u="none" strike="noStrike" dirty="0">
                           <a:solidFill>
                             <a:srgbClr val="000000"/>
                           </a:solidFill>
@@ -13000,7 +13000,7 @@
         </p:nvGrpSpPr>
         <p:grpSpPr>
           <a:xfrm>
-            <a:off x="3168467" y="3741967"/>
+            <a:off x="3168467" y="3717253"/>
             <a:ext cx="5432425" cy="521970"/>
             <a:chOff x="7193" y="3484"/>
             <a:chExt cx="8122" cy="822"/>
@@ -22342,271 +22342,94 @@
           </a:prstGeom>
         </p:spPr>
       </p:pic>
-      <p:grpSp>
-        <p:nvGrpSpPr>
-          <p:cNvPr id="2" name="组合 1">
+      <p:cxnSp>
+        <p:nvCxnSpPr>
+          <p:cNvPr id="3" name="直接连接符 12">
             <a:extLst>
               <a:ext uri="{FF2B5EF4-FFF2-40B4-BE49-F238E27FC236}">
-                <a16:creationId xmlns:a16="http://schemas.microsoft.com/office/drawing/2014/main" id="{A2F95578-114D-5354-5266-CF385DC02386}"/>
+                <a16:creationId xmlns:a16="http://schemas.microsoft.com/office/drawing/2014/main" id="{494C3B72-8710-AAE0-046F-AC4F5D8C7296}"/>
               </a:ext>
             </a:extLst>
           </p:cNvPr>
-          <p:cNvGrpSpPr/>
+          <p:cNvCxnSpPr>
+            <a:cxnSpLocks/>
+          </p:cNvCxnSpPr>
           <p:nvPr/>
-        </p:nvGrpSpPr>
-        <p:grpSpPr>
+        </p:nvCxnSpPr>
+        <p:spPr>
           <a:xfrm>
-            <a:off x="3055651" y="3098734"/>
-            <a:ext cx="5432425" cy="523240"/>
-            <a:chOff x="7193" y="3484"/>
-            <a:chExt cx="8122" cy="824"/>
+            <a:off x="3055651" y="3360354"/>
+            <a:ext cx="3724174" cy="0"/>
           </a:xfrm>
-        </p:grpSpPr>
-        <p:cxnSp>
-          <p:nvCxnSpPr>
-            <p:cNvPr id="3" name="直接连接符 12">
-              <a:extLst>
-                <a:ext uri="{FF2B5EF4-FFF2-40B4-BE49-F238E27FC236}">
-                  <a16:creationId xmlns:a16="http://schemas.microsoft.com/office/drawing/2014/main" id="{494C3B72-8710-AAE0-046F-AC4F5D8C7296}"/>
-                </a:ext>
-              </a:extLst>
-            </p:cNvPr>
-            <p:cNvCxnSpPr>
-              <a:endCxn id="28" idx="1"/>
-            </p:cNvCxnSpPr>
-            <p:nvPr/>
-          </p:nvCxnSpPr>
-          <p:spPr>
-            <a:xfrm>
-              <a:off x="7193" y="3896"/>
-              <a:ext cx="5568" cy="0"/>
-            </a:xfrm>
-            <a:prstGeom prst="line">
-              <a:avLst/>
-            </a:prstGeom>
-            <a:ln w="57150">
-              <a:solidFill>
-                <a:srgbClr val="FF0000"/>
-              </a:solidFill>
-              <a:prstDash val="sysDash"/>
-            </a:ln>
-          </p:spPr>
-          <p:style>
-            <a:lnRef idx="1">
-              <a:schemeClr val="accent1"/>
-            </a:lnRef>
-            <a:fillRef idx="0">
-              <a:schemeClr val="accent1"/>
-            </a:fillRef>
-            <a:effectRef idx="0">
-              <a:schemeClr val="accent1"/>
-            </a:effectRef>
-            <a:fontRef idx="minor">
-              <a:schemeClr val="tx1"/>
-            </a:fontRef>
-          </p:style>
-        </p:cxnSp>
-        <p:sp>
-          <p:nvSpPr>
-            <p:cNvPr id="28" name="文本框 27">
-              <a:extLst>
-                <a:ext uri="{FF2B5EF4-FFF2-40B4-BE49-F238E27FC236}">
-                  <a16:creationId xmlns:a16="http://schemas.microsoft.com/office/drawing/2014/main" id="{2F52BEBF-8222-8996-76AB-342AB974B178}"/>
-                </a:ext>
-              </a:extLst>
-            </p:cNvPr>
-            <p:cNvSpPr txBox="1"/>
-            <p:nvPr/>
-          </p:nvSpPr>
-          <p:spPr>
-            <a:xfrm>
-              <a:off x="12761" y="3484"/>
-              <a:ext cx="2554" cy="824"/>
-            </a:xfrm>
-            <a:prstGeom prst="rect">
-              <a:avLst/>
-            </a:prstGeom>
-            <a:noFill/>
-          </p:spPr>
-          <p:txBody>
-            <a:bodyPr wrap="square" rtlCol="0">
-              <a:spAutoFit/>
-            </a:bodyPr>
-            <a:lstStyle/>
-            <a:p>
-              <a:r>
-                <a:rPr lang="zh-CN" altLang="en-US" sz="2800" dirty="0">
-                  <a:ln w="0"/>
-                  <a:solidFill>
-                    <a:srgbClr val="FF0000"/>
-                  </a:solidFill>
-                  <a:effectLst>
-                    <a:outerShdw blurRad="38100" dist="25400" dir="5400000" algn="ctr" rotWithShape="0">
-                      <a:srgbClr val="6E747A">
-                        <a:alpha val="43000"/>
-                      </a:srgbClr>
-                    </a:outerShdw>
-                  </a:effectLst>
-                  <a:latin typeface="楷体" panose="02010609060101010101" pitchFamily="49" charset="-122"/>
-                  <a:ea typeface="楷体" panose="02010609060101010101" pitchFamily="49" charset="-122"/>
-                  <a:cs typeface="楷体" panose="02010609060101010101" pitchFamily="49" charset="-122"/>
-                </a:rPr>
-                <a:t>最大数</a:t>
-              </a:r>
-              <a:r>
-                <a:rPr lang="en-US" altLang="zh-CN" sz="2800" dirty="0">
-                  <a:ln w="0"/>
-                  <a:solidFill>
-                    <a:srgbClr val="FF0000"/>
-                  </a:solidFill>
-                  <a:effectLst>
-                    <a:outerShdw blurRad="38100" dist="25400" dir="5400000" algn="ctr" rotWithShape="0">
-                      <a:srgbClr val="6E747A">
-                        <a:alpha val="43000"/>
-                      </a:srgbClr>
-                    </a:outerShdw>
-                  </a:effectLst>
-                  <a:latin typeface="楷体" panose="02010609060101010101" pitchFamily="49" charset="-122"/>
-                  <a:ea typeface="楷体" panose="02010609060101010101" pitchFamily="49" charset="-122"/>
-                  <a:cs typeface="楷体" panose="02010609060101010101" pitchFamily="49" charset="-122"/>
-                </a:rPr>
-                <a:t> </a:t>
-              </a:r>
-              <a:endParaRPr lang="zh-CN" altLang="en-US" sz="2800" dirty="0">
-                <a:ln w="0"/>
-                <a:solidFill>
-                  <a:srgbClr val="FF0000"/>
-                </a:solidFill>
-                <a:effectLst>
-                  <a:outerShdw blurRad="38100" dist="25400" dir="5400000" algn="ctr" rotWithShape="0">
-                    <a:srgbClr val="6E747A">
-                      <a:alpha val="43000"/>
-                    </a:srgbClr>
-                  </a:outerShdw>
-                </a:effectLst>
-                <a:latin typeface="楷体" panose="02010609060101010101" pitchFamily="49" charset="-122"/>
-                <a:ea typeface="楷体" panose="02010609060101010101" pitchFamily="49" charset="-122"/>
-                <a:cs typeface="楷体" panose="02010609060101010101" pitchFamily="49" charset="-122"/>
-              </a:endParaRPr>
-            </a:p>
-          </p:txBody>
-        </p:sp>
-      </p:grpSp>
-      <p:grpSp>
-        <p:nvGrpSpPr>
-          <p:cNvPr id="29" name="组合 28">
+          <a:prstGeom prst="line">
+            <a:avLst/>
+          </a:prstGeom>
+          <a:ln w="57150">
+            <a:solidFill>
+              <a:srgbClr val="FF0000"/>
+            </a:solidFill>
+            <a:prstDash val="sysDash"/>
+          </a:ln>
+        </p:spPr>
+        <p:style>
+          <a:lnRef idx="1">
+            <a:schemeClr val="accent1"/>
+          </a:lnRef>
+          <a:fillRef idx="0">
+            <a:schemeClr val="accent1"/>
+          </a:fillRef>
+          <a:effectRef idx="0">
+            <a:schemeClr val="accent1"/>
+          </a:effectRef>
+          <a:fontRef idx="minor">
+            <a:schemeClr val="tx1"/>
+          </a:fontRef>
+        </p:style>
+      </p:cxnSp>
+      <p:cxnSp>
+        <p:nvCxnSpPr>
+          <p:cNvPr id="34" name="直接连接符 12">
             <a:extLst>
               <a:ext uri="{FF2B5EF4-FFF2-40B4-BE49-F238E27FC236}">
-                <a16:creationId xmlns:a16="http://schemas.microsoft.com/office/drawing/2014/main" id="{AF0040AC-0003-9064-1D94-E14FB2D0A90E}"/>
+                <a16:creationId xmlns:a16="http://schemas.microsoft.com/office/drawing/2014/main" id="{B51CB7A9-D896-C5FF-8153-960BE69BD411}"/>
               </a:ext>
             </a:extLst>
           </p:cNvPr>
-          <p:cNvGrpSpPr/>
+          <p:cNvCxnSpPr>
+            <a:cxnSpLocks/>
+          </p:cNvCxnSpPr>
           <p:nvPr/>
-        </p:nvGrpSpPr>
-        <p:grpSpPr>
+        </p:nvCxnSpPr>
+        <p:spPr>
           <a:xfrm>
-            <a:off x="3062179" y="4692590"/>
-            <a:ext cx="5432425" cy="523240"/>
-            <a:chOff x="7193" y="3484"/>
-            <a:chExt cx="8122" cy="824"/>
+            <a:off x="3062179" y="4954210"/>
+            <a:ext cx="3724174" cy="0"/>
           </a:xfrm>
-        </p:grpSpPr>
-        <p:cxnSp>
-          <p:nvCxnSpPr>
-            <p:cNvPr id="34" name="直接连接符 12">
-              <a:extLst>
-                <a:ext uri="{FF2B5EF4-FFF2-40B4-BE49-F238E27FC236}">
-                  <a16:creationId xmlns:a16="http://schemas.microsoft.com/office/drawing/2014/main" id="{B51CB7A9-D896-C5FF-8153-960BE69BD411}"/>
-                </a:ext>
-              </a:extLst>
-            </p:cNvPr>
-            <p:cNvCxnSpPr>
-              <a:endCxn id="48" idx="1"/>
-            </p:cNvCxnSpPr>
-            <p:nvPr/>
-          </p:nvCxnSpPr>
-          <p:spPr>
-            <a:xfrm>
-              <a:off x="7193" y="3896"/>
-              <a:ext cx="5568" cy="0"/>
-            </a:xfrm>
-            <a:prstGeom prst="line">
-              <a:avLst/>
-            </a:prstGeom>
-            <a:ln w="57150">
-              <a:solidFill>
-                <a:srgbClr val="FF0000"/>
-              </a:solidFill>
-              <a:prstDash val="sysDash"/>
-            </a:ln>
-          </p:spPr>
-          <p:style>
-            <a:lnRef idx="1">
-              <a:schemeClr val="accent1"/>
-            </a:lnRef>
-            <a:fillRef idx="0">
-              <a:schemeClr val="accent1"/>
-            </a:fillRef>
-            <a:effectRef idx="0">
-              <a:schemeClr val="accent1"/>
-            </a:effectRef>
-            <a:fontRef idx="minor">
-              <a:schemeClr val="tx1"/>
-            </a:fontRef>
-          </p:style>
-        </p:cxnSp>
-        <p:sp>
-          <p:nvSpPr>
-            <p:cNvPr id="48" name="文本框 47">
-              <a:extLst>
-                <a:ext uri="{FF2B5EF4-FFF2-40B4-BE49-F238E27FC236}">
-                  <a16:creationId xmlns:a16="http://schemas.microsoft.com/office/drawing/2014/main" id="{D63674AE-F6B1-4B40-B26B-98DD4AF3B8DF}"/>
-                </a:ext>
-              </a:extLst>
-            </p:cNvPr>
-            <p:cNvSpPr txBox="1"/>
-            <p:nvPr/>
-          </p:nvSpPr>
-          <p:spPr>
-            <a:xfrm>
-              <a:off x="12761" y="3484"/>
-              <a:ext cx="2554" cy="824"/>
-            </a:xfrm>
-            <a:prstGeom prst="rect">
-              <a:avLst/>
-            </a:prstGeom>
-            <a:noFill/>
-          </p:spPr>
-          <p:txBody>
-            <a:bodyPr wrap="square" rtlCol="0">
-              <a:spAutoFit/>
-            </a:bodyPr>
-            <a:lstStyle/>
-            <a:p>
-              <a:r>
-                <a:rPr lang="zh-CN" altLang="en-US" sz="2800" dirty="0">
-                  <a:ln w="0"/>
-                  <a:solidFill>
-                    <a:srgbClr val="FF0000"/>
-                  </a:solidFill>
-                  <a:effectLst>
-                    <a:outerShdw blurRad="38100" dist="25400" dir="5400000" algn="ctr" rotWithShape="0">
-                      <a:srgbClr val="6E747A">
-                        <a:alpha val="43000"/>
-                      </a:srgbClr>
-                    </a:outerShdw>
-                  </a:effectLst>
-                  <a:latin typeface="楷体" panose="02010609060101010101" pitchFamily="49" charset="-122"/>
-                  <a:ea typeface="楷体" panose="02010609060101010101" pitchFamily="49" charset="-122"/>
-                  <a:cs typeface="楷体" panose="02010609060101010101" pitchFamily="49" charset="-122"/>
-                </a:rPr>
-                <a:t>最小数</a:t>
-              </a:r>
-            </a:p>
-          </p:txBody>
-        </p:sp>
-      </p:grpSp>
+          <a:prstGeom prst="line">
+            <a:avLst/>
+          </a:prstGeom>
+          <a:ln w="57150">
+            <a:solidFill>
+              <a:srgbClr val="FF0000"/>
+            </a:solidFill>
+            <a:prstDash val="sysDash"/>
+          </a:ln>
+        </p:spPr>
+        <p:style>
+          <a:lnRef idx="1">
+            <a:schemeClr val="accent1"/>
+          </a:lnRef>
+          <a:fillRef idx="0">
+            <a:schemeClr val="accent1"/>
+          </a:fillRef>
+          <a:effectRef idx="0">
+            <a:schemeClr val="accent1"/>
+          </a:effectRef>
+          <a:fontRef idx="minor">
+            <a:schemeClr val="tx1"/>
+          </a:fontRef>
+        </p:style>
+      </p:cxnSp>
       <p:grpSp>
         <p:nvGrpSpPr>
           <p:cNvPr id="49" name="组合 48">
@@ -22793,6 +22616,141 @@
           </a:p>
         </p:txBody>
       </p:sp>
+      <p:sp>
+        <p:nvSpPr>
+          <p:cNvPr id="30" name="文本框 29">
+            <a:extLst>
+              <a:ext uri="{FF2B5EF4-FFF2-40B4-BE49-F238E27FC236}">
+                <a16:creationId xmlns:a16="http://schemas.microsoft.com/office/drawing/2014/main" id="{971B919F-8622-AFCD-68B1-FD05D586810B}"/>
+              </a:ext>
+            </a:extLst>
+          </p:cNvPr>
+          <p:cNvSpPr txBox="1"/>
+          <p:nvPr/>
+        </p:nvSpPr>
+        <p:spPr>
+          <a:xfrm>
+            <a:off x="6786353" y="3080581"/>
+            <a:ext cx="1708251" cy="523240"/>
+          </a:xfrm>
+          <a:prstGeom prst="rect">
+            <a:avLst/>
+          </a:prstGeom>
+          <a:noFill/>
+        </p:spPr>
+        <p:txBody>
+          <a:bodyPr wrap="square" rtlCol="0">
+            <a:spAutoFit/>
+          </a:bodyPr>
+          <a:lstStyle/>
+          <a:p>
+            <a:r>
+              <a:rPr lang="zh-CN" altLang="en-US" sz="2800" dirty="0">
+                <a:ln w="0"/>
+                <a:solidFill>
+                  <a:srgbClr val="FF0000"/>
+                </a:solidFill>
+                <a:effectLst>
+                  <a:outerShdw blurRad="38100" dist="25400" dir="5400000" algn="ctr" rotWithShape="0">
+                    <a:srgbClr val="6E747A">
+                      <a:alpha val="43000"/>
+                    </a:srgbClr>
+                  </a:outerShdw>
+                </a:effectLst>
+                <a:latin typeface="楷体" panose="02010609060101010101" pitchFamily="49" charset="-122"/>
+                <a:ea typeface="楷体" panose="02010609060101010101" pitchFamily="49" charset="-122"/>
+                <a:cs typeface="楷体" panose="02010609060101010101" pitchFamily="49" charset="-122"/>
+              </a:rPr>
+              <a:t>最大数</a:t>
+            </a:r>
+            <a:r>
+              <a:rPr lang="en-US" altLang="zh-CN" sz="2800" dirty="0">
+                <a:ln w="0"/>
+                <a:solidFill>
+                  <a:srgbClr val="FF0000"/>
+                </a:solidFill>
+                <a:effectLst>
+                  <a:outerShdw blurRad="38100" dist="25400" dir="5400000" algn="ctr" rotWithShape="0">
+                    <a:srgbClr val="6E747A">
+                      <a:alpha val="43000"/>
+                    </a:srgbClr>
+                  </a:outerShdw>
+                </a:effectLst>
+                <a:latin typeface="楷体" panose="02010609060101010101" pitchFamily="49" charset="-122"/>
+                <a:ea typeface="楷体" panose="02010609060101010101" pitchFamily="49" charset="-122"/>
+                <a:cs typeface="楷体" panose="02010609060101010101" pitchFamily="49" charset="-122"/>
+              </a:rPr>
+              <a:t> </a:t>
+            </a:r>
+            <a:endParaRPr lang="zh-CN" altLang="en-US" sz="2800" dirty="0">
+              <a:ln w="0"/>
+              <a:solidFill>
+                <a:srgbClr val="FF0000"/>
+              </a:solidFill>
+              <a:effectLst>
+                <a:outerShdw blurRad="38100" dist="25400" dir="5400000" algn="ctr" rotWithShape="0">
+                  <a:srgbClr val="6E747A">
+                    <a:alpha val="43000"/>
+                  </a:srgbClr>
+                </a:outerShdw>
+              </a:effectLst>
+              <a:latin typeface="楷体" panose="02010609060101010101" pitchFamily="49" charset="-122"/>
+              <a:ea typeface="楷体" panose="02010609060101010101" pitchFamily="49" charset="-122"/>
+              <a:cs typeface="楷体" panose="02010609060101010101" pitchFamily="49" charset="-122"/>
+            </a:endParaRPr>
+          </a:p>
+        </p:txBody>
+      </p:sp>
+      <p:sp>
+        <p:nvSpPr>
+          <p:cNvPr id="31" name="文本框 30">
+            <a:extLst>
+              <a:ext uri="{FF2B5EF4-FFF2-40B4-BE49-F238E27FC236}">
+                <a16:creationId xmlns:a16="http://schemas.microsoft.com/office/drawing/2014/main" id="{E4D4E040-26AE-6703-B660-DBCA5000CB52}"/>
+              </a:ext>
+            </a:extLst>
+          </p:cNvPr>
+          <p:cNvSpPr txBox="1"/>
+          <p:nvPr/>
+        </p:nvSpPr>
+        <p:spPr>
+          <a:xfrm>
+            <a:off x="6748963" y="4656625"/>
+            <a:ext cx="1708251" cy="523240"/>
+          </a:xfrm>
+          <a:prstGeom prst="rect">
+            <a:avLst/>
+          </a:prstGeom>
+          <a:noFill/>
+        </p:spPr>
+        <p:txBody>
+          <a:bodyPr wrap="square" rtlCol="0">
+            <a:spAutoFit/>
+          </a:bodyPr>
+          <a:lstStyle/>
+          <a:p>
+            <a:r>
+              <a:rPr lang="zh-CN" altLang="en-US" sz="2800" dirty="0">
+                <a:ln w="0"/>
+                <a:solidFill>
+                  <a:srgbClr val="FF0000"/>
+                </a:solidFill>
+                <a:effectLst>
+                  <a:outerShdw blurRad="38100" dist="25400" dir="5400000" algn="ctr" rotWithShape="0">
+                    <a:srgbClr val="6E747A">
+                      <a:alpha val="43000"/>
+                    </a:srgbClr>
+                  </a:outerShdw>
+                </a:effectLst>
+                <a:latin typeface="楷体" panose="02010609060101010101" pitchFamily="49" charset="-122"/>
+                <a:ea typeface="楷体" panose="02010609060101010101" pitchFamily="49" charset="-122"/>
+                <a:cs typeface="楷体" panose="02010609060101010101" pitchFamily="49" charset="-122"/>
+              </a:rPr>
+              <a:t>最小数</a:t>
+            </a:r>
+          </a:p>
+        </p:txBody>
+      </p:sp>
     </p:spTree>
   </p:cSld>
   <p:clrMapOvr>
@@ -22819,7 +22777,7 @@
                             </p:stCondLst>
                             <p:childTnLst>
                               <p:par>
-                                <p:cTn id="5" presetID="22" presetClass="entr" presetSubtype="8" fill="hold" nodeType="clickEffect">
+                                <p:cTn id="5" presetID="16" presetClass="entr" presetSubtype="21" fill="hold" nodeType="clickEffect">
                                   <p:stCondLst>
                                     <p:cond delay="0"/>
                                   </p:stCondLst>
@@ -22832,7 +22790,219 @@
                                           </p:stCondLst>
                                         </p:cTn>
                                         <p:tgtEl>
-                                          <p:spTgt spid="2"/>
+                                          <p:spTgt spid="3"/>
+                                        </p:tgtEl>
+                                        <p:attrNameLst>
+                                          <p:attrName>style.visibility</p:attrName>
+                                        </p:attrNameLst>
+                                      </p:cBhvr>
+                                      <p:to>
+                                        <p:strVal val="visible"/>
+                                      </p:to>
+                                    </p:set>
+                                    <p:animEffect transition="in" filter="barn(inVertical)">
+                                      <p:cBhvr>
+                                        <p:cTn id="7" dur="500"/>
+                                        <p:tgtEl>
+                                          <p:spTgt spid="3"/>
+                                        </p:tgtEl>
+                                      </p:cBhvr>
+                                    </p:animEffect>
+                                  </p:childTnLst>
+                                </p:cTn>
+                              </p:par>
+                            </p:childTnLst>
+                          </p:cTn>
+                        </p:par>
+                      </p:childTnLst>
+                    </p:cTn>
+                  </p:par>
+                  <p:par>
+                    <p:cTn id="8" fill="hold">
+                      <p:stCondLst>
+                        <p:cond delay="indefinite"/>
+                      </p:stCondLst>
+                      <p:childTnLst>
+                        <p:par>
+                          <p:cTn id="9" fill="hold">
+                            <p:stCondLst>
+                              <p:cond delay="0"/>
+                            </p:stCondLst>
+                            <p:childTnLst>
+                              <p:par>
+                                <p:cTn id="10" presetID="16" presetClass="entr" presetSubtype="21" fill="hold" nodeType="clickEffect">
+                                  <p:stCondLst>
+                                    <p:cond delay="0"/>
+                                  </p:stCondLst>
+                                  <p:childTnLst>
+                                    <p:set>
+                                      <p:cBhvr>
+                                        <p:cTn id="11" dur="1" fill="hold">
+                                          <p:stCondLst>
+                                            <p:cond delay="0"/>
+                                          </p:stCondLst>
+                                        </p:cTn>
+                                        <p:tgtEl>
+                                          <p:spTgt spid="34"/>
+                                        </p:tgtEl>
+                                        <p:attrNameLst>
+                                          <p:attrName>style.visibility</p:attrName>
+                                        </p:attrNameLst>
+                                      </p:cBhvr>
+                                      <p:to>
+                                        <p:strVal val="visible"/>
+                                      </p:to>
+                                    </p:set>
+                                    <p:animEffect transition="in" filter="barn(inVertical)">
+                                      <p:cBhvr>
+                                        <p:cTn id="12" dur="500"/>
+                                        <p:tgtEl>
+                                          <p:spTgt spid="34"/>
+                                        </p:tgtEl>
+                                      </p:cBhvr>
+                                    </p:animEffect>
+                                  </p:childTnLst>
+                                </p:cTn>
+                              </p:par>
+                            </p:childTnLst>
+                          </p:cTn>
+                        </p:par>
+                      </p:childTnLst>
+                    </p:cTn>
+                  </p:par>
+                  <p:par>
+                    <p:cTn id="13" fill="hold">
+                      <p:stCondLst>
+                        <p:cond delay="indefinite"/>
+                      </p:stCondLst>
+                      <p:childTnLst>
+                        <p:par>
+                          <p:cTn id="14" fill="hold">
+                            <p:stCondLst>
+                              <p:cond delay="0"/>
+                            </p:stCondLst>
+                            <p:childTnLst>
+                              <p:par>
+                                <p:cTn id="15" presetID="16" presetClass="entr" presetSubtype="21" fill="hold" grpId="0" nodeType="clickEffect">
+                                  <p:stCondLst>
+                                    <p:cond delay="0"/>
+                                  </p:stCondLst>
+                                  <p:childTnLst>
+                                    <p:set>
+                                      <p:cBhvr>
+                                        <p:cTn id="16" dur="1" fill="hold">
+                                          <p:stCondLst>
+                                            <p:cond delay="0"/>
+                                          </p:stCondLst>
+                                        </p:cTn>
+                                        <p:tgtEl>
+                                          <p:spTgt spid="30"/>
+                                        </p:tgtEl>
+                                        <p:attrNameLst>
+                                          <p:attrName>style.visibility</p:attrName>
+                                        </p:attrNameLst>
+                                      </p:cBhvr>
+                                      <p:to>
+                                        <p:strVal val="visible"/>
+                                      </p:to>
+                                    </p:set>
+                                    <p:animEffect transition="in" filter="barn(inVertical)">
+                                      <p:cBhvr>
+                                        <p:cTn id="17" dur="500"/>
+                                        <p:tgtEl>
+                                          <p:spTgt spid="30"/>
+                                        </p:tgtEl>
+                                      </p:cBhvr>
+                                    </p:animEffect>
+                                  </p:childTnLst>
+                                </p:cTn>
+                              </p:par>
+                            </p:childTnLst>
+                          </p:cTn>
+                        </p:par>
+                      </p:childTnLst>
+                    </p:cTn>
+                  </p:par>
+                  <p:par>
+                    <p:cTn id="18" fill="hold">
+                      <p:stCondLst>
+                        <p:cond delay="indefinite"/>
+                      </p:stCondLst>
+                      <p:childTnLst>
+                        <p:par>
+                          <p:cTn id="19" fill="hold">
+                            <p:stCondLst>
+                              <p:cond delay="0"/>
+                            </p:stCondLst>
+                            <p:childTnLst>
+                              <p:par>
+                                <p:cTn id="20" presetID="16" presetClass="entr" presetSubtype="21" fill="hold" grpId="0" nodeType="clickEffect">
+                                  <p:stCondLst>
+                                    <p:cond delay="0"/>
+                                  </p:stCondLst>
+                                  <p:childTnLst>
+                                    <p:set>
+                                      <p:cBhvr>
+                                        <p:cTn id="21" dur="1" fill="hold">
+                                          <p:stCondLst>
+                                            <p:cond delay="0"/>
+                                          </p:stCondLst>
+                                        </p:cTn>
+                                        <p:tgtEl>
+                                          <p:spTgt spid="31"/>
+                                        </p:tgtEl>
+                                        <p:attrNameLst>
+                                          <p:attrName>style.visibility</p:attrName>
+                                        </p:attrNameLst>
+                                      </p:cBhvr>
+                                      <p:to>
+                                        <p:strVal val="visible"/>
+                                      </p:to>
+                                    </p:set>
+                                    <p:animEffect transition="in" filter="barn(inVertical)">
+                                      <p:cBhvr>
+                                        <p:cTn id="22" dur="500"/>
+                                        <p:tgtEl>
+                                          <p:spTgt spid="31"/>
+                                        </p:tgtEl>
+                                      </p:cBhvr>
+                                    </p:animEffect>
+                                  </p:childTnLst>
+                                </p:cTn>
+                              </p:par>
+                            </p:childTnLst>
+                          </p:cTn>
+                        </p:par>
+                      </p:childTnLst>
+                    </p:cTn>
+                  </p:par>
+                  <p:par>
+                    <p:cTn id="23" fill="hold">
+                      <p:stCondLst>
+                        <p:cond delay="indefinite"/>
+                      </p:stCondLst>
+                      <p:childTnLst>
+                        <p:par>
+                          <p:cTn id="24" fill="hold">
+                            <p:stCondLst>
+                              <p:cond delay="0"/>
+                            </p:stCondLst>
+                            <p:childTnLst>
+                              <p:par>
+                                <p:cTn id="25" presetID="22" presetClass="entr" presetSubtype="8" fill="hold" nodeType="clickEffect">
+                                  <p:stCondLst>
+                                    <p:cond delay="0"/>
+                                  </p:stCondLst>
+                                  <p:childTnLst>
+                                    <p:set>
+                                      <p:cBhvr>
+                                        <p:cTn id="26" dur="1" fill="hold">
+                                          <p:stCondLst>
+                                            <p:cond delay="0"/>
+                                          </p:stCondLst>
+                                        </p:cTn>
+                                        <p:tgtEl>
+                                          <p:spTgt spid="49"/>
                                         </p:tgtEl>
                                         <p:attrNameLst>
                                           <p:attrName>style.visibility</p:attrName>
@@ -22844,9 +23014,9 @@
                                     </p:set>
                                     <p:animEffect transition="in" filter="wipe(left)">
                                       <p:cBhvr>
-                                        <p:cTn id="7" dur="500"/>
+                                        <p:cTn id="27" dur="500"/>
                                         <p:tgtEl>
-                                          <p:spTgt spid="2"/>
+                                          <p:spTgt spid="49"/>
                                         </p:tgtEl>
                                       </p:cBhvr>
                                     </p:animEffect>
@@ -22857,7 +23027,7 @@
                                         <p:cTn display="0" masterRel="sameClick">
                                           <p:stCondLst>
                                             <p:cond evt="begin" delay="0">
-                                              <p:tn val="5"/>
+                                              <p:tn val="25"/>
                                             </p:cond>
                                           </p:stCondLst>
                                           <p:endCondLst>
@@ -22883,178 +23053,26 @@
                     </p:cTn>
                   </p:par>
                   <p:par>
-                    <p:cTn id="8" fill="hold">
+                    <p:cTn id="28" fill="hold">
                       <p:stCondLst>
                         <p:cond delay="indefinite"/>
                       </p:stCondLst>
                       <p:childTnLst>
                         <p:par>
-                          <p:cTn id="9" fill="hold">
+                          <p:cTn id="29" fill="hold">
                             <p:stCondLst>
                               <p:cond delay="0"/>
                             </p:stCondLst>
                             <p:childTnLst>
                               <p:par>
-                                <p:cTn id="10" presetID="22" presetClass="entr" presetSubtype="8" fill="hold" nodeType="clickEffect">
+                                <p:cTn id="30" presetID="3" presetClass="entr" presetSubtype="10" fill="hold" grpId="0" nodeType="clickEffect">
                                   <p:stCondLst>
                                     <p:cond delay="0"/>
                                   </p:stCondLst>
                                   <p:childTnLst>
                                     <p:set>
                                       <p:cBhvr>
-                                        <p:cTn id="11" dur="1" fill="hold">
-                                          <p:stCondLst>
-                                            <p:cond delay="0"/>
-                                          </p:stCondLst>
-                                        </p:cTn>
-                                        <p:tgtEl>
-                                          <p:spTgt spid="29"/>
-                                        </p:tgtEl>
-                                        <p:attrNameLst>
-                                          <p:attrName>style.visibility</p:attrName>
-                                        </p:attrNameLst>
-                                      </p:cBhvr>
-                                      <p:to>
-                                        <p:strVal val="visible"/>
-                                      </p:to>
-                                    </p:set>
-                                    <p:animEffect transition="in" filter="wipe(left)">
-                                      <p:cBhvr>
-                                        <p:cTn id="12" dur="500"/>
-                                        <p:tgtEl>
-                                          <p:spTgt spid="29"/>
-                                        </p:tgtEl>
-                                      </p:cBhvr>
-                                    </p:animEffect>
-                                  </p:childTnLst>
-                                  <p:subTnLst>
-                                    <p:audio>
-                                      <p:cMediaNode>
-                                        <p:cTn display="0" masterRel="sameClick">
-                                          <p:stCondLst>
-                                            <p:cond evt="begin" delay="0">
-                                              <p:tn val="10"/>
-                                            </p:cond>
-                                          </p:stCondLst>
-                                          <p:endCondLst>
-                                            <p:cond evt="onStopAudio" delay="0">
-                                              <p:tgtEl>
-                                                <p:sldTgt/>
-                                              </p:tgtEl>
-                                            </p:cond>
-                                          </p:endCondLst>
-                                        </p:cTn>
-                                        <p:tgtEl>
-                                          <p:sndTgt r:embed="rId3" name="suction.wav"/>
-                                        </p:tgtEl>
-                                      </p:cMediaNode>
-                                    </p:audio>
-                                  </p:subTnLst>
-                                </p:cTn>
-                              </p:par>
-                            </p:childTnLst>
-                          </p:cTn>
-                        </p:par>
-                      </p:childTnLst>
-                    </p:cTn>
-                  </p:par>
-                  <p:par>
-                    <p:cTn id="13" fill="hold">
-                      <p:stCondLst>
-                        <p:cond delay="indefinite"/>
-                      </p:stCondLst>
-                      <p:childTnLst>
-                        <p:par>
-                          <p:cTn id="14" fill="hold">
-                            <p:stCondLst>
-                              <p:cond delay="0"/>
-                            </p:stCondLst>
-                            <p:childTnLst>
-                              <p:par>
-                                <p:cTn id="15" presetID="22" presetClass="entr" presetSubtype="8" fill="hold" nodeType="clickEffect">
-                                  <p:stCondLst>
-                                    <p:cond delay="0"/>
-                                  </p:stCondLst>
-                                  <p:childTnLst>
-                                    <p:set>
-                                      <p:cBhvr>
-                                        <p:cTn id="16" dur="1" fill="hold">
-                                          <p:stCondLst>
-                                            <p:cond delay="0"/>
-                                          </p:stCondLst>
-                                        </p:cTn>
-                                        <p:tgtEl>
-                                          <p:spTgt spid="49"/>
-                                        </p:tgtEl>
-                                        <p:attrNameLst>
-                                          <p:attrName>style.visibility</p:attrName>
-                                        </p:attrNameLst>
-                                      </p:cBhvr>
-                                      <p:to>
-                                        <p:strVal val="visible"/>
-                                      </p:to>
-                                    </p:set>
-                                    <p:animEffect transition="in" filter="wipe(left)">
-                                      <p:cBhvr>
-                                        <p:cTn id="17" dur="500"/>
-                                        <p:tgtEl>
-                                          <p:spTgt spid="49"/>
-                                        </p:tgtEl>
-                                      </p:cBhvr>
-                                    </p:animEffect>
-                                  </p:childTnLst>
-                                  <p:subTnLst>
-                                    <p:audio>
-                                      <p:cMediaNode>
-                                        <p:cTn display="0" masterRel="sameClick">
-                                          <p:stCondLst>
-                                            <p:cond evt="begin" delay="0">
-                                              <p:tn val="15"/>
-                                            </p:cond>
-                                          </p:stCondLst>
-                                          <p:endCondLst>
-                                            <p:cond evt="onStopAudio" delay="0">
-                                              <p:tgtEl>
-                                                <p:sldTgt/>
-                                              </p:tgtEl>
-                                            </p:cond>
-                                          </p:endCondLst>
-                                        </p:cTn>
-                                        <p:tgtEl>
-                                          <p:sndTgt r:embed="rId3" name="suction.wav"/>
-                                        </p:tgtEl>
-                                      </p:cMediaNode>
-                                    </p:audio>
-                                  </p:subTnLst>
-                                </p:cTn>
-                              </p:par>
-                            </p:childTnLst>
-                          </p:cTn>
-                        </p:par>
-                      </p:childTnLst>
-                    </p:cTn>
-                  </p:par>
-                  <p:par>
-                    <p:cTn id="18" fill="hold">
-                      <p:stCondLst>
-                        <p:cond delay="indefinite"/>
-                      </p:stCondLst>
-                      <p:childTnLst>
-                        <p:par>
-                          <p:cTn id="19" fill="hold">
-                            <p:stCondLst>
-                              <p:cond delay="0"/>
-                            </p:stCondLst>
-                            <p:childTnLst>
-                              <p:par>
-                                <p:cTn id="20" presetID="3" presetClass="entr" presetSubtype="10" fill="hold" grpId="0" nodeType="clickEffect">
-                                  <p:stCondLst>
-                                    <p:cond delay="0"/>
-                                  </p:stCondLst>
-                                  <p:childTnLst>
-                                    <p:set>
-                                      <p:cBhvr>
-                                        <p:cTn id="21" dur="1" fill="hold">
+                                        <p:cTn id="31" dur="1" fill="hold">
                                           <p:stCondLst>
                                             <p:cond delay="0"/>
                                           </p:stCondLst>
@@ -23072,7 +23090,7 @@
                                     </p:set>
                                     <p:animEffect transition="in" filter="blinds(horizontal)">
                                       <p:cBhvr>
-                                        <p:cTn id="22" dur="500"/>
+                                        <p:cTn id="32" dur="500"/>
                                         <p:tgtEl>
                                           <p:spTgt spid="52"/>
                                         </p:tgtEl>
@@ -23110,6 +23128,8 @@
     </p:tnLst>
     <p:bldLst>
       <p:bldP spid="52" grpId="0"/>
+      <p:bldP spid="30" grpId="0"/>
+      <p:bldP spid="31" grpId="0"/>
     </p:bldLst>
   </p:timing>
 </p:sld>
@@ -23147,7 +23167,7 @@
           <p:nvPr>
             <p:extLst>
               <p:ext uri="{D42A27DB-BD31-4B8C-83A1-F6EECF244321}">
-                <p14:modId xmlns:p14="http://schemas.microsoft.com/office/powerpoint/2010/main" val="1980040756"/>
+                <p14:modId xmlns:p14="http://schemas.microsoft.com/office/powerpoint/2010/main" val="2769243969"/>
               </p:ext>
             </p:extLst>
           </p:nvPr>
@@ -23235,7 +23255,7 @@
                         <a:buNone/>
                       </a:pPr>
                       <a:r>
-                        <a:rPr lang="zh-CN" altLang="en-US" sz="1200" b="0" i="0" u="none" strike="noStrike">
+                        <a:rPr lang="zh-CN" altLang="en-US" sz="1200" b="0" i="0" u="none" strike="noStrike" dirty="0">
                           <a:solidFill>
                             <a:srgbClr val="000000"/>
                           </a:solidFill>
@@ -25025,7 +25045,7 @@
                         <a:buNone/>
                       </a:pPr>
                       <a:r>
-                        <a:rPr lang="zh-CN" altLang="en-US" sz="1200" b="0" i="0" u="none" strike="noStrike">
+                        <a:rPr lang="zh-CN" altLang="en-US" sz="1200" b="0" i="0" u="none" strike="noStrike" dirty="0">
                           <a:solidFill>
                             <a:srgbClr val="000000"/>
                           </a:solidFill>
@@ -30679,7 +30699,39 @@
         </p:nvSpPr>
         <p:spPr>
           <a:xfrm>
-            <a:off x="3391593" y="3303842"/>
+            <a:off x="3391593" y="3563335"/>
+            <a:ext cx="371475" cy="369332"/>
+          </a:xfrm>
+          <a:prstGeom prst="rect">
+            <a:avLst/>
+          </a:prstGeom>
+          <a:noFill/>
+        </p:spPr>
+        <p:txBody>
+          <a:bodyPr wrap="square" rtlCol="0">
+            <a:spAutoFit/>
+          </a:bodyPr>
+          <a:lstStyle/>
+          <a:p>
+            <a:r>
+              <a:rPr lang="en-US" altLang="zh-CN" b="1" dirty="0">
+                <a:latin typeface="楷体" panose="02010609060101010101" pitchFamily="49" charset="-122"/>
+                <a:ea typeface="楷体" panose="02010609060101010101" pitchFamily="49" charset="-122"/>
+              </a:rPr>
+              <a:t>8</a:t>
+            </a:r>
+          </a:p>
+        </p:txBody>
+      </p:sp>
+      <p:sp>
+        <p:nvSpPr>
+          <p:cNvPr id="28" name="文本框 27"/>
+          <p:cNvSpPr txBox="1"/>
+          <p:nvPr/>
+        </p:nvSpPr>
+        <p:spPr>
+          <a:xfrm>
+            <a:off x="4154492" y="3240455"/>
             <a:ext cx="371475" cy="369332"/>
           </a:xfrm>
           <a:prstGeom prst="rect">
@@ -30705,13 +30757,13 @@
       </p:sp>
       <p:sp>
         <p:nvSpPr>
-          <p:cNvPr id="28" name="文本框 27"/>
+          <p:cNvPr id="29" name="文本框 28"/>
           <p:cNvSpPr txBox="1"/>
           <p:nvPr/>
         </p:nvSpPr>
         <p:spPr>
           <a:xfrm>
-            <a:off x="4140746" y="3880910"/>
+            <a:off x="4923922" y="3878368"/>
             <a:ext cx="371475" cy="369332"/>
           </a:xfrm>
           <a:prstGeom prst="rect">
@@ -30731,38 +30783,6 @@
                 <a:ea typeface="楷体" panose="02010609060101010101" pitchFamily="49" charset="-122"/>
               </a:rPr>
               <a:t>7</a:t>
-            </a:r>
-          </a:p>
-        </p:txBody>
-      </p:sp>
-      <p:sp>
-        <p:nvSpPr>
-          <p:cNvPr id="29" name="文本框 28"/>
-          <p:cNvSpPr txBox="1"/>
-          <p:nvPr/>
-        </p:nvSpPr>
-        <p:spPr>
-          <a:xfrm>
-            <a:off x="4919249" y="3582087"/>
-            <a:ext cx="371475" cy="369332"/>
-          </a:xfrm>
-          <a:prstGeom prst="rect">
-            <a:avLst/>
-          </a:prstGeom>
-          <a:noFill/>
-        </p:spPr>
-        <p:txBody>
-          <a:bodyPr wrap="square" rtlCol="0">
-            <a:spAutoFit/>
-          </a:bodyPr>
-          <a:lstStyle/>
-          <a:p>
-            <a:r>
-              <a:rPr lang="en-US" altLang="zh-CN" b="1" dirty="0">
-                <a:latin typeface="楷体" panose="02010609060101010101" pitchFamily="49" charset="-122"/>
-                <a:ea typeface="楷体" panose="02010609060101010101" pitchFamily="49" charset="-122"/>
-              </a:rPr>
-              <a:t>8</a:t>
             </a:r>
           </a:p>
         </p:txBody>
@@ -30807,7 +30827,7 @@
         </p:nvSpPr>
         <p:spPr>
           <a:xfrm>
-            <a:off x="5685633" y="4848408"/>
+            <a:off x="5685633" y="4230568"/>
             <a:ext cx="371475" cy="369332"/>
           </a:xfrm>
           <a:prstGeom prst="rect">
@@ -30826,7 +30846,7 @@
                 <a:latin typeface="楷体" panose="02010609060101010101" pitchFamily="49" charset="-122"/>
                 <a:ea typeface="楷体" panose="02010609060101010101" pitchFamily="49" charset="-122"/>
               </a:rPr>
-              <a:t>4</a:t>
+              <a:t>6</a:t>
             </a:r>
           </a:p>
         </p:txBody>
@@ -30841,7 +30861,7 @@
             </p:custDataLst>
             <p:extLst>
               <p:ext uri="{D42A27DB-BD31-4B8C-83A1-F6EECF244321}">
-                <p14:modId xmlns:p14="http://schemas.microsoft.com/office/powerpoint/2010/main" val="3140811669"/>
+                <p14:modId xmlns:p14="http://schemas.microsoft.com/office/powerpoint/2010/main" val="1176639451"/>
               </p:ext>
             </p:extLst>
           </p:nvPr>
@@ -31276,7 +31296,7 @@
                       </a:pPr>
                       <a:r>
                         <a:rPr lang="en-US" altLang="zh-CN" sz="2400" dirty="0"/>
-                        <a:t>7</a:t>
+                        <a:t>8</a:t>
                       </a:r>
                     </a:p>
                   </a:txBody>
@@ -31292,7 +31312,7 @@
                       </a:pPr>
                       <a:r>
                         <a:rPr lang="en-US" altLang="zh-CN" sz="2400" dirty="0"/>
-                        <a:t>8</a:t>
+                        <a:t>7</a:t>
                       </a:r>
                     </a:p>
                   </a:txBody>
@@ -31565,8 +31585,8 @@
         </p:blipFill>
         <p:spPr>
           <a:xfrm>
-            <a:off x="3348681" y="3618214"/>
-            <a:ext cx="395416" cy="2863811"/>
+            <a:off x="3348681" y="3929630"/>
+            <a:ext cx="395416" cy="2552395"/>
           </a:xfrm>
           <a:prstGeom prst="rect">
             <a:avLst/>
@@ -31595,8 +31615,8 @@
         </p:blipFill>
         <p:spPr>
           <a:xfrm>
-            <a:off x="4105821" y="4250243"/>
-            <a:ext cx="395416" cy="2231782"/>
+            <a:off x="4105821" y="3620090"/>
+            <a:ext cx="395416" cy="2861935"/>
           </a:xfrm>
           <a:prstGeom prst="rect">
             <a:avLst/>
@@ -31625,8 +31645,8 @@
         </p:blipFill>
         <p:spPr>
           <a:xfrm>
-            <a:off x="4877461" y="3934227"/>
-            <a:ext cx="395416" cy="2547797"/>
+            <a:off x="4877461" y="4250242"/>
+            <a:ext cx="395416" cy="2231782"/>
           </a:xfrm>
           <a:prstGeom prst="rect">
             <a:avLst/>
@@ -31655,7 +31675,7 @@
         </p:blipFill>
         <p:spPr>
           <a:xfrm>
-            <a:off x="5634547" y="2649007"/>
+            <a:off x="5635289" y="2633116"/>
             <a:ext cx="395416" cy="3820918"/>
           </a:xfrm>
           <a:prstGeom prst="rect">
@@ -31977,7 +31997,7 @@
         </p:nvGrpSpPr>
         <p:grpSpPr>
           <a:xfrm>
-            <a:off x="2968951" y="3671339"/>
+            <a:off x="2976571" y="3662321"/>
             <a:ext cx="5432425" cy="521970"/>
             <a:chOff x="7193" y="3503"/>
             <a:chExt cx="8122" cy="822"/>
@@ -32135,8 +32155,8 @@
         </p:blipFill>
         <p:spPr>
           <a:xfrm>
-            <a:off x="5636744" y="5196313"/>
-            <a:ext cx="395416" cy="1273614"/>
+            <a:off x="5638468" y="4555946"/>
+            <a:ext cx="395416" cy="1914310"/>
           </a:xfrm>
           <a:prstGeom prst="rect">
             <a:avLst/>
@@ -32157,10 +32177,10 @@
         </p:nvGrpSpPr>
         <p:grpSpPr>
           <a:xfrm>
-            <a:off x="2961649" y="4007567"/>
-            <a:ext cx="5432425" cy="521970"/>
+            <a:off x="2961649" y="3834572"/>
+            <a:ext cx="5568871" cy="523240"/>
             <a:chOff x="7193" y="3503"/>
-            <a:chExt cx="8122" cy="822"/>
+            <a:chExt cx="8326" cy="824"/>
           </a:xfrm>
         </p:grpSpPr>
         <p:cxnSp>
@@ -32173,14 +32193,15 @@
               </a:extLst>
             </p:cNvPr>
             <p:cNvCxnSpPr>
+              <a:cxnSpLocks/>
               <a:endCxn id="71" idx="1"/>
             </p:cNvCxnSpPr>
             <p:nvPr/>
           </p:nvCxnSpPr>
           <p:spPr>
-            <a:xfrm flipV="1">
-              <a:off x="7193" y="3914"/>
-              <a:ext cx="5568" cy="1"/>
+            <a:xfrm>
+              <a:off x="7193" y="3915"/>
+              <a:ext cx="5568" cy="0"/>
             </a:xfrm>
             <a:prstGeom prst="line">
               <a:avLst/>
@@ -32222,7 +32243,7 @@
           <p:spPr>
             <a:xfrm>
               <a:off x="12761" y="3503"/>
-              <a:ext cx="2554" cy="822"/>
+              <a:ext cx="2758" cy="824"/>
             </a:xfrm>
             <a:prstGeom prst="rect">
               <a:avLst/>
@@ -32271,157 +32292,7 @@
                   <a:ea typeface="楷体" panose="02010609060101010101" pitchFamily="49" charset="-122"/>
                   <a:cs typeface="楷体" panose="02010609060101010101" pitchFamily="49" charset="-122"/>
                 </a:rPr>
-                <a:t>7 </a:t>
-              </a:r>
-              <a:endParaRPr lang="zh-CN" altLang="en-US" sz="2800" dirty="0">
-                <a:ln w="0"/>
-                <a:solidFill>
-                  <a:srgbClr val="FF0000"/>
-                </a:solidFill>
-                <a:effectLst>
-                  <a:outerShdw blurRad="38100" dist="25400" dir="5400000" algn="ctr" rotWithShape="0">
-                    <a:srgbClr val="6E747A">
-                      <a:alpha val="43000"/>
-                    </a:srgbClr>
-                  </a:outerShdw>
-                </a:effectLst>
-                <a:latin typeface="楷体" panose="02010609060101010101" pitchFamily="49" charset="-122"/>
-                <a:ea typeface="楷体" panose="02010609060101010101" pitchFamily="49" charset="-122"/>
-                <a:cs typeface="楷体" panose="02010609060101010101" pitchFamily="49" charset="-122"/>
-              </a:endParaRPr>
-            </a:p>
-          </p:txBody>
-        </p:sp>
-      </p:grpSp>
-      <p:grpSp>
-        <p:nvGrpSpPr>
-          <p:cNvPr id="72" name="组合 71">
-            <a:extLst>
-              <a:ext uri="{FF2B5EF4-FFF2-40B4-BE49-F238E27FC236}">
-                <a16:creationId xmlns:a16="http://schemas.microsoft.com/office/drawing/2014/main" id="{E87D0CDC-2448-9D65-48B9-06C671217D17}"/>
-              </a:ext>
-            </a:extLst>
-          </p:cNvPr>
-          <p:cNvGrpSpPr/>
-          <p:nvPr/>
-        </p:nvGrpSpPr>
-        <p:grpSpPr>
-          <a:xfrm>
-            <a:off x="2968951" y="3663586"/>
-            <a:ext cx="5432425" cy="521970"/>
-            <a:chOff x="7193" y="3503"/>
-            <a:chExt cx="8122" cy="822"/>
-          </a:xfrm>
-        </p:grpSpPr>
-        <p:cxnSp>
-          <p:nvCxnSpPr>
-            <p:cNvPr id="73" name="直接连接符 12">
-              <a:extLst>
-                <a:ext uri="{FF2B5EF4-FFF2-40B4-BE49-F238E27FC236}">
-                  <a16:creationId xmlns:a16="http://schemas.microsoft.com/office/drawing/2014/main" id="{26FE0EC4-FB95-2D76-AD2C-4A49363CFBB9}"/>
-                </a:ext>
-              </a:extLst>
-            </p:cNvPr>
-            <p:cNvCxnSpPr>
-              <a:endCxn id="74" idx="1"/>
-            </p:cNvCxnSpPr>
-            <p:nvPr/>
-          </p:nvCxnSpPr>
-          <p:spPr>
-            <a:xfrm flipV="1">
-              <a:off x="7193" y="3914"/>
-              <a:ext cx="5568" cy="1"/>
-            </a:xfrm>
-            <a:prstGeom prst="line">
-              <a:avLst/>
-            </a:prstGeom>
-            <a:ln w="57150">
-              <a:solidFill>
-                <a:srgbClr val="FF0000"/>
-              </a:solidFill>
-              <a:prstDash val="sysDash"/>
-            </a:ln>
-          </p:spPr>
-          <p:style>
-            <a:lnRef idx="1">
-              <a:schemeClr val="accent1"/>
-            </a:lnRef>
-            <a:fillRef idx="0">
-              <a:schemeClr val="accent1"/>
-            </a:fillRef>
-            <a:effectRef idx="0">
-              <a:schemeClr val="accent1"/>
-            </a:effectRef>
-            <a:fontRef idx="minor">
-              <a:schemeClr val="tx1"/>
-            </a:fontRef>
-          </p:style>
-        </p:cxnSp>
-        <p:sp>
-          <p:nvSpPr>
-            <p:cNvPr id="74" name="文本框 73">
-              <a:extLst>
-                <a:ext uri="{FF2B5EF4-FFF2-40B4-BE49-F238E27FC236}">
-                  <a16:creationId xmlns:a16="http://schemas.microsoft.com/office/drawing/2014/main" id="{B6B0144F-F058-4DC1-F87F-F019DAF1DA78}"/>
-                </a:ext>
-              </a:extLst>
-            </p:cNvPr>
-            <p:cNvSpPr txBox="1"/>
-            <p:nvPr/>
-          </p:nvSpPr>
-          <p:spPr>
-            <a:xfrm>
-              <a:off x="12761" y="3503"/>
-              <a:ext cx="2554" cy="822"/>
-            </a:xfrm>
-            <a:prstGeom prst="rect">
-              <a:avLst/>
-            </a:prstGeom>
-            <a:noFill/>
-          </p:spPr>
-          <p:txBody>
-            <a:bodyPr wrap="square" rtlCol="0">
-              <a:spAutoFit/>
-            </a:bodyPr>
-            <a:lstStyle/>
-            <a:p>
-              <a:r>
-                <a:rPr lang="zh-CN" altLang="en-US" sz="2800" dirty="0">
-                  <a:ln w="0"/>
-                  <a:solidFill>
-                    <a:srgbClr val="FF0000"/>
-                  </a:solidFill>
-                  <a:effectLst>
-                    <a:outerShdw blurRad="38100" dist="25400" dir="5400000" algn="ctr" rotWithShape="0">
-                      <a:srgbClr val="6E747A">
-                        <a:alpha val="43000"/>
-                      </a:srgbClr>
-                    </a:outerShdw>
-                  </a:effectLst>
-                  <a:latin typeface="楷体" panose="02010609060101010101" pitchFamily="49" charset="-122"/>
-                  <a:ea typeface="楷体" panose="02010609060101010101" pitchFamily="49" charset="-122"/>
-                  <a:cs typeface="楷体" panose="02010609060101010101" pitchFamily="49" charset="-122"/>
-                </a:rPr>
-                <a:t>平均数</a:t>
-              </a:r>
-              <a:r>
-                <a:rPr lang="en-US" altLang="zh-CN" sz="2800" dirty="0">
-                  <a:ln w="0"/>
-                  <a:solidFill>
-                    <a:srgbClr val="FF0000"/>
-                  </a:solidFill>
-                  <a:effectLst>
-                    <a:outerShdw blurRad="38100" dist="25400" dir="5400000" algn="ctr" rotWithShape="0">
-                      <a:srgbClr val="6E747A">
-                        <a:alpha val="43000"/>
-                      </a:srgbClr>
-                    </a:outerShdw>
-                  </a:effectLst>
-                  <a:latin typeface="楷体" panose="02010609060101010101" pitchFamily="49" charset="-122"/>
-                  <a:ea typeface="楷体" panose="02010609060101010101" pitchFamily="49" charset="-122"/>
-                  <a:cs typeface="楷体" panose="02010609060101010101" pitchFamily="49" charset="-122"/>
-                </a:rPr>
-                <a:t>8 </a:t>
+                <a:t>7.5 </a:t>
               </a:r>
               <a:endParaRPr lang="zh-CN" altLang="en-US" sz="2800" dirty="0">
                 <a:ln w="0"/>
@@ -32501,7 +32372,7 @@
         </p:blipFill>
         <p:spPr>
           <a:xfrm>
-            <a:off x="5638215" y="3924735"/>
+            <a:off x="5650080" y="3916973"/>
             <a:ext cx="395416" cy="2545190"/>
           </a:xfrm>
           <a:prstGeom prst="rect">
@@ -32583,6 +32454,156 @@
           </a:p>
         </p:txBody>
       </p:sp>
+      <p:grpSp>
+        <p:nvGrpSpPr>
+          <p:cNvPr id="2" name="组合 1">
+            <a:extLst>
+              <a:ext uri="{FF2B5EF4-FFF2-40B4-BE49-F238E27FC236}">
+                <a16:creationId xmlns:a16="http://schemas.microsoft.com/office/drawing/2014/main" id="{826D542C-9C9D-4BD9-2281-540CD00B84F9}"/>
+              </a:ext>
+            </a:extLst>
+          </p:cNvPr>
+          <p:cNvGrpSpPr/>
+          <p:nvPr/>
+        </p:nvGrpSpPr>
+        <p:grpSpPr>
+          <a:xfrm>
+            <a:off x="2984191" y="3668645"/>
+            <a:ext cx="5432425" cy="521970"/>
+            <a:chOff x="7193" y="3503"/>
+            <a:chExt cx="8122" cy="822"/>
+          </a:xfrm>
+        </p:grpSpPr>
+        <p:cxnSp>
+          <p:nvCxnSpPr>
+            <p:cNvPr id="5" name="直接连接符 12">
+              <a:extLst>
+                <a:ext uri="{FF2B5EF4-FFF2-40B4-BE49-F238E27FC236}">
+                  <a16:creationId xmlns:a16="http://schemas.microsoft.com/office/drawing/2014/main" id="{FBA406DA-9794-6E68-DA8B-87B29B182250}"/>
+                </a:ext>
+              </a:extLst>
+            </p:cNvPr>
+            <p:cNvCxnSpPr>
+              <a:endCxn id="7" idx="1"/>
+            </p:cNvCxnSpPr>
+            <p:nvPr/>
+          </p:nvCxnSpPr>
+          <p:spPr>
+            <a:xfrm flipV="1">
+              <a:off x="7193" y="3914"/>
+              <a:ext cx="5568" cy="1"/>
+            </a:xfrm>
+            <a:prstGeom prst="line">
+              <a:avLst/>
+            </a:prstGeom>
+            <a:ln w="57150">
+              <a:solidFill>
+                <a:srgbClr val="FF0000"/>
+              </a:solidFill>
+              <a:prstDash val="sysDash"/>
+            </a:ln>
+          </p:spPr>
+          <p:style>
+            <a:lnRef idx="1">
+              <a:schemeClr val="accent1"/>
+            </a:lnRef>
+            <a:fillRef idx="0">
+              <a:schemeClr val="accent1"/>
+            </a:fillRef>
+            <a:effectRef idx="0">
+              <a:schemeClr val="accent1"/>
+            </a:effectRef>
+            <a:fontRef idx="minor">
+              <a:schemeClr val="tx1"/>
+            </a:fontRef>
+          </p:style>
+        </p:cxnSp>
+        <p:sp>
+          <p:nvSpPr>
+            <p:cNvPr id="7" name="文本框 6">
+              <a:extLst>
+                <a:ext uri="{FF2B5EF4-FFF2-40B4-BE49-F238E27FC236}">
+                  <a16:creationId xmlns:a16="http://schemas.microsoft.com/office/drawing/2014/main" id="{24887752-2F3A-E152-EE89-8309C5240014}"/>
+                </a:ext>
+              </a:extLst>
+            </p:cNvPr>
+            <p:cNvSpPr txBox="1"/>
+            <p:nvPr/>
+          </p:nvSpPr>
+          <p:spPr>
+            <a:xfrm>
+              <a:off x="12761" y="3503"/>
+              <a:ext cx="2554" cy="822"/>
+            </a:xfrm>
+            <a:prstGeom prst="rect">
+              <a:avLst/>
+            </a:prstGeom>
+            <a:noFill/>
+          </p:spPr>
+          <p:txBody>
+            <a:bodyPr wrap="square" rtlCol="0">
+              <a:spAutoFit/>
+            </a:bodyPr>
+            <a:lstStyle/>
+            <a:p>
+              <a:r>
+                <a:rPr lang="zh-CN" altLang="en-US" sz="2800" dirty="0">
+                  <a:ln w="0"/>
+                  <a:solidFill>
+                    <a:srgbClr val="FF0000"/>
+                  </a:solidFill>
+                  <a:effectLst>
+                    <a:outerShdw blurRad="38100" dist="25400" dir="5400000" algn="ctr" rotWithShape="0">
+                      <a:srgbClr val="6E747A">
+                        <a:alpha val="43000"/>
+                      </a:srgbClr>
+                    </a:outerShdw>
+                  </a:effectLst>
+                  <a:latin typeface="楷体" panose="02010609060101010101" pitchFamily="49" charset="-122"/>
+                  <a:ea typeface="楷体" panose="02010609060101010101" pitchFamily="49" charset="-122"/>
+                  <a:cs typeface="楷体" panose="02010609060101010101" pitchFamily="49" charset="-122"/>
+                </a:rPr>
+                <a:t>平均数</a:t>
+              </a:r>
+              <a:r>
+                <a:rPr lang="en-US" altLang="zh-CN" sz="2800" dirty="0">
+                  <a:ln w="0"/>
+                  <a:solidFill>
+                    <a:srgbClr val="FF0000"/>
+                  </a:solidFill>
+                  <a:effectLst>
+                    <a:outerShdw blurRad="38100" dist="25400" dir="5400000" algn="ctr" rotWithShape="0">
+                      <a:srgbClr val="6E747A">
+                        <a:alpha val="43000"/>
+                      </a:srgbClr>
+                    </a:outerShdw>
+                  </a:effectLst>
+                  <a:latin typeface="楷体" panose="02010609060101010101" pitchFamily="49" charset="-122"/>
+                  <a:ea typeface="楷体" panose="02010609060101010101" pitchFamily="49" charset="-122"/>
+                  <a:cs typeface="楷体" panose="02010609060101010101" pitchFamily="49" charset="-122"/>
+                </a:rPr>
+                <a:t>8 </a:t>
+              </a:r>
+              <a:endParaRPr lang="zh-CN" altLang="en-US" sz="2800" dirty="0">
+                <a:ln w="0"/>
+                <a:solidFill>
+                  <a:srgbClr val="FF0000"/>
+                </a:solidFill>
+                <a:effectLst>
+                  <a:outerShdw blurRad="38100" dist="25400" dir="5400000" algn="ctr" rotWithShape="0">
+                    <a:srgbClr val="6E747A">
+                      <a:alpha val="43000"/>
+                    </a:srgbClr>
+                  </a:outerShdw>
+                </a:effectLst>
+                <a:latin typeface="楷体" panose="02010609060101010101" pitchFamily="49" charset="-122"/>
+                <a:ea typeface="楷体" panose="02010609060101010101" pitchFamily="49" charset="-122"/>
+                <a:cs typeface="楷体" panose="02010609060101010101" pitchFamily="49" charset="-122"/>
+              </a:endParaRPr>
+            </a:p>
+          </p:txBody>
+        </p:sp>
+      </p:grpSp>
     </p:spTree>
   </p:cSld>
   <p:clrMapOvr>
@@ -32900,15 +32921,33 @@
                                   </p:childTnLst>
                                 </p:cTn>
                               </p:par>
+                            </p:childTnLst>
+                          </p:cTn>
+                        </p:par>
+                      </p:childTnLst>
+                    </p:cTn>
+                  </p:par>
+                  <p:par>
+                    <p:cTn id="22" fill="hold">
+                      <p:stCondLst>
+                        <p:cond delay="indefinite"/>
+                      </p:stCondLst>
+                      <p:childTnLst>
+                        <p:par>
+                          <p:cTn id="23" fill="hold">
+                            <p:stCondLst>
+                              <p:cond delay="0"/>
+                            </p:stCondLst>
+                            <p:childTnLst>
                               <p:par>
-                                <p:cTn id="22" presetID="3" presetClass="exit" presetSubtype="10" fill="hold" nodeType="withEffect">
+                                <p:cTn id="24" presetID="3" presetClass="exit" presetSubtype="10" fill="hold" nodeType="clickEffect">
                                   <p:stCondLst>
                                     <p:cond delay="0"/>
                                   </p:stCondLst>
                                   <p:childTnLst>
                                     <p:animEffect transition="out" filter="blinds(horizontal)">
                                       <p:cBhvr>
-                                        <p:cTn id="23" dur="500"/>
+                                        <p:cTn id="25" dur="500"/>
                                         <p:tgtEl>
                                           <p:spTgt spid="49"/>
                                         </p:tgtEl>
@@ -32916,7 +32955,7 @@
                                     </p:animEffect>
                                     <p:set>
                                       <p:cBhvr>
-                                        <p:cTn id="24" dur="1" fill="hold">
+                                        <p:cTn id="26" dur="1" fill="hold">
                                           <p:stCondLst>
                                             <p:cond delay="499"/>
                                           </p:stCondLst>
@@ -32935,26 +32974,8 @@
                                   </p:childTnLst>
                                 </p:cTn>
                               </p:par>
-                            </p:childTnLst>
-                          </p:cTn>
-                        </p:par>
-                      </p:childTnLst>
-                    </p:cTn>
-                  </p:par>
-                  <p:par>
-                    <p:cTn id="25" fill="hold">
-                      <p:stCondLst>
-                        <p:cond delay="indefinite"/>
-                      </p:stCondLst>
-                      <p:childTnLst>
-                        <p:par>
-                          <p:cTn id="26" fill="hold">
-                            <p:stCondLst>
-                              <p:cond delay="0"/>
-                            </p:stCondLst>
-                            <p:childTnLst>
                               <p:par>
-                                <p:cTn id="27" presetID="22" presetClass="entr" presetSubtype="8" fill="hold" nodeType="clickEffect">
+                                <p:cTn id="27" presetID="22" presetClass="entr" presetSubtype="8" fill="hold" nodeType="withEffect">
                                   <p:stCondLst>
                                     <p:cond delay="0"/>
                                   </p:stCondLst>
@@ -33135,7 +33156,7 @@
                                 </p:cTn>
                               </p:par>
                               <p:par>
-                                <p:cTn id="41" presetID="22" presetClass="entr" presetSubtype="8" fill="hold" nodeType="withEffect">
+                                <p:cTn id="41" presetID="1" presetClass="entr" presetSubtype="0" fill="hold" nodeType="withEffect">
                                   <p:stCondLst>
                                     <p:cond delay="0"/>
                                   </p:stCondLst>
@@ -33158,14 +33179,6 @@
                                         <p:strVal val="visible"/>
                                       </p:to>
                                     </p:set>
-                                    <p:animEffect transition="in" filter="wipe(left)">
-                                      <p:cBhvr>
-                                        <p:cTn id="43" dur="500"/>
-                                        <p:tgtEl>
-                                          <p:spTgt spid="65"/>
-                                        </p:tgtEl>
-                                      </p:cBhvr>
-                                    </p:animEffect>
                                   </p:childTnLst>
                                   <p:subTnLst>
                                     <p:audio>
@@ -33192,68 +33205,15 @@
                                   </p:subTnLst>
                                 </p:cTn>
                               </p:par>
-                            </p:childTnLst>
-                          </p:cTn>
-                        </p:par>
-                      </p:childTnLst>
-                    </p:cTn>
-                  </p:par>
-                  <p:par>
-                    <p:cTn id="44" fill="hold">
-                      <p:stCondLst>
-                        <p:cond delay="indefinite"/>
-                      </p:stCondLst>
-                      <p:childTnLst>
-                        <p:par>
-                          <p:cTn id="45" fill="hold">
-                            <p:stCondLst>
-                              <p:cond delay="0"/>
-                            </p:stCondLst>
-                            <p:childTnLst>
                               <p:par>
-                                <p:cTn id="46" presetID="3" presetClass="exit" presetSubtype="10" fill="hold" nodeType="clickEffect">
-                                  <p:stCondLst>
-                                    <p:cond delay="0"/>
-                                  </p:stCondLst>
-                                  <p:childTnLst>
-                                    <p:animEffect transition="out" filter="blinds(horizontal)">
-                                      <p:cBhvr>
-                                        <p:cTn id="47" dur="500"/>
-                                        <p:tgtEl>
-                                          <p:spTgt spid="65"/>
-                                        </p:tgtEl>
-                                      </p:cBhvr>
-                                    </p:animEffect>
-                                    <p:set>
-                                      <p:cBhvr>
-                                        <p:cTn id="48" dur="1" fill="hold">
-                                          <p:stCondLst>
-                                            <p:cond delay="499"/>
-                                          </p:stCondLst>
-                                        </p:cTn>
-                                        <p:tgtEl>
-                                          <p:spTgt spid="65"/>
-                                        </p:tgtEl>
-                                        <p:attrNameLst>
-                                          <p:attrName>style.visibility</p:attrName>
-                                        </p:attrNameLst>
-                                      </p:cBhvr>
-                                      <p:to>
-                                        <p:strVal val="hidden"/>
-                                      </p:to>
-                                    </p:set>
-                                  </p:childTnLst>
-                                </p:cTn>
-                              </p:par>
-                              <p:par>
-                                <p:cTn id="49" presetID="37" presetClass="entr" presetSubtype="0" fill="hold" nodeType="withEffect">
+                                <p:cTn id="43" presetID="37" presetClass="entr" presetSubtype="0" fill="hold" nodeType="withEffect">
                                   <p:stCondLst>
                                     <p:cond delay="0"/>
                                   </p:stCondLst>
                                   <p:childTnLst>
                                     <p:set>
                                       <p:cBhvr>
-                                        <p:cTn id="50" dur="1" fill="hold">
+                                        <p:cTn id="44" dur="1" fill="hold">
                                           <p:stCondLst>
                                             <p:cond delay="0"/>
                                           </p:stCondLst>
@@ -33271,7 +33231,7 @@
                                     </p:set>
                                     <p:animEffect transition="in" filter="fade">
                                       <p:cBhvr>
-                                        <p:cTn id="51" dur="1000"/>
+                                        <p:cTn id="45" dur="1000"/>
                                         <p:tgtEl>
                                           <p:spTgt spid="68"/>
                                         </p:tgtEl>
@@ -33279,7 +33239,7 @@
                                     </p:animEffect>
                                     <p:anim calcmode="lin" valueType="num">
                                       <p:cBhvr>
-                                        <p:cTn id="52" dur="1000" fill="hold"/>
+                                        <p:cTn id="46" dur="1000" fill="hold"/>
                                         <p:tgtEl>
                                           <p:spTgt spid="68"/>
                                         </p:tgtEl>
@@ -33302,7 +33262,7 @@
                                     </p:anim>
                                     <p:anim calcmode="lin" valueType="num">
                                       <p:cBhvr>
-                                        <p:cTn id="53" dur="900" decel="100000" fill="hold"/>
+                                        <p:cTn id="47" dur="900" decel="100000" fill="hold"/>
                                         <p:tgtEl>
                                           <p:spTgt spid="68"/>
                                         </p:tgtEl>
@@ -33325,7 +33285,7 @@
                                     </p:anim>
                                     <p:anim calcmode="lin" valueType="num">
                                       <p:cBhvr>
-                                        <p:cTn id="54" dur="100" accel="100000" fill="hold">
+                                        <p:cTn id="48" dur="100" accel="100000" fill="hold">
                                           <p:stCondLst>
                                             <p:cond delay="900"/>
                                           </p:stCondLst>
@@ -33354,14 +33314,14 @@
                                 </p:cTn>
                               </p:par>
                               <p:par>
-                                <p:cTn id="55" presetID="37" presetClass="entr" presetSubtype="0" fill="hold" grpId="0" nodeType="withEffect">
+                                <p:cTn id="49" presetID="37" presetClass="entr" presetSubtype="0" fill="hold" grpId="0" nodeType="withEffect">
                                   <p:stCondLst>
                                     <p:cond delay="0"/>
                                   </p:stCondLst>
                                   <p:childTnLst>
                                     <p:set>
                                       <p:cBhvr>
-                                        <p:cTn id="56" dur="1" fill="hold">
+                                        <p:cTn id="50" dur="1" fill="hold">
                                           <p:stCondLst>
                                             <p:cond delay="0"/>
                                           </p:stCondLst>
@@ -33379,7 +33339,7 @@
                                     </p:set>
                                     <p:animEffect transition="in" filter="fade">
                                       <p:cBhvr>
-                                        <p:cTn id="57" dur="1000"/>
+                                        <p:cTn id="51" dur="1000"/>
                                         <p:tgtEl>
                                           <p:spTgt spid="44"/>
                                         </p:tgtEl>
@@ -33387,7 +33347,7 @@
                                     </p:animEffect>
                                     <p:anim calcmode="lin" valueType="num">
                                       <p:cBhvr>
-                                        <p:cTn id="58" dur="1000" fill="hold"/>
+                                        <p:cTn id="52" dur="1000" fill="hold"/>
                                         <p:tgtEl>
                                           <p:spTgt spid="44"/>
                                         </p:tgtEl>
@@ -33410,7 +33370,7 @@
                                     </p:anim>
                                     <p:anim calcmode="lin" valueType="num">
                                       <p:cBhvr>
-                                        <p:cTn id="59" dur="900" decel="100000" fill="hold"/>
+                                        <p:cTn id="53" dur="900" decel="100000" fill="hold"/>
                                         <p:tgtEl>
                                           <p:spTgt spid="44"/>
                                         </p:tgtEl>
@@ -33433,7 +33393,7 @@
                                     </p:anim>
                                     <p:anim calcmode="lin" valueType="num">
                                       <p:cBhvr>
-                                        <p:cTn id="60" dur="100" accel="100000" fill="hold">
+                                        <p:cTn id="54" dur="100" accel="100000" fill="hold">
                                           <p:stCondLst>
                                             <p:cond delay="900"/>
                                           </p:stCondLst>
@@ -33468,26 +33428,26 @@
                     </p:cTn>
                   </p:par>
                   <p:par>
-                    <p:cTn id="61" fill="hold">
+                    <p:cTn id="55" fill="hold">
                       <p:stCondLst>
                         <p:cond delay="indefinite"/>
                       </p:stCondLst>
                       <p:childTnLst>
                         <p:par>
-                          <p:cTn id="62" fill="hold">
+                          <p:cTn id="56" fill="hold">
                             <p:stCondLst>
                               <p:cond delay="0"/>
                             </p:stCondLst>
                             <p:childTnLst>
                               <p:par>
-                                <p:cTn id="63" presetID="22" presetClass="entr" presetSubtype="8" fill="hold" nodeType="clickEffect">
+                                <p:cTn id="57" presetID="22" presetClass="entr" presetSubtype="8" fill="hold" nodeType="clickEffect">
                                   <p:stCondLst>
                                     <p:cond delay="0"/>
                                   </p:stCondLst>
                                   <p:childTnLst>
                                     <p:set>
                                       <p:cBhvr>
-                                        <p:cTn id="64" dur="1" fill="hold">
+                                        <p:cTn id="58" dur="1" fill="hold">
                                           <p:stCondLst>
                                             <p:cond delay="0"/>
                                           </p:stCondLst>
@@ -33505,7 +33465,7 @@
                                     </p:set>
                                     <p:animEffect transition="in" filter="wipe(left)">
                                       <p:cBhvr>
-                                        <p:cTn id="65" dur="500"/>
+                                        <p:cTn id="59" dur="500"/>
                                         <p:tgtEl>
                                           <p:spTgt spid="69"/>
                                         </p:tgtEl>
@@ -33518,7 +33478,215 @@
                                         <p:cTn display="0" masterRel="sameClick">
                                           <p:stCondLst>
                                             <p:cond evt="begin" delay="0">
-                                              <p:tn val="63"/>
+                                              <p:tn val="57"/>
+                                            </p:cond>
+                                          </p:stCondLst>
+                                          <p:endCondLst>
+                                            <p:cond evt="onStopAudio" delay="0">
+                                              <p:tgtEl>
+                                                <p:sldTgt/>
+                                              </p:tgtEl>
+                                            </p:cond>
+                                          </p:endCondLst>
+                                        </p:cTn>
+                                        <p:tgtEl>
+                                          <p:sndTgt r:embed="rId3" name="suction.wav"/>
+                                        </p:tgtEl>
+                                      </p:cMediaNode>
+                                    </p:audio>
+                                  </p:subTnLst>
+                                </p:cTn>
+                              </p:par>
+                              <p:par>
+                                <p:cTn id="60" presetID="3" presetClass="exit" presetSubtype="10" fill="hold" nodeType="withEffect">
+                                  <p:stCondLst>
+                                    <p:cond delay="0"/>
+                                  </p:stCondLst>
+                                  <p:childTnLst>
+                                    <p:animEffect transition="out" filter="blinds(horizontal)">
+                                      <p:cBhvr>
+                                        <p:cTn id="61" dur="500"/>
+                                        <p:tgtEl>
+                                          <p:spTgt spid="65"/>
+                                        </p:tgtEl>
+                                      </p:cBhvr>
+                                    </p:animEffect>
+                                    <p:set>
+                                      <p:cBhvr>
+                                        <p:cTn id="62" dur="1" fill="hold">
+                                          <p:stCondLst>
+                                            <p:cond delay="499"/>
+                                          </p:stCondLst>
+                                        </p:cTn>
+                                        <p:tgtEl>
+                                          <p:spTgt spid="65"/>
+                                        </p:tgtEl>
+                                        <p:attrNameLst>
+                                          <p:attrName>style.visibility</p:attrName>
+                                        </p:attrNameLst>
+                                      </p:cBhvr>
+                                      <p:to>
+                                        <p:strVal val="hidden"/>
+                                      </p:to>
+                                    </p:set>
+                                  </p:childTnLst>
+                                </p:cTn>
+                              </p:par>
+                            </p:childTnLst>
+                          </p:cTn>
+                        </p:par>
+                      </p:childTnLst>
+                    </p:cTn>
+                  </p:par>
+                  <p:par>
+                    <p:cTn id="63" fill="hold">
+                      <p:stCondLst>
+                        <p:cond delay="indefinite"/>
+                      </p:stCondLst>
+                      <p:childTnLst>
+                        <p:par>
+                          <p:cTn id="64" fill="hold">
+                            <p:stCondLst>
+                              <p:cond delay="0"/>
+                            </p:stCondLst>
+                            <p:childTnLst>
+                              <p:par>
+                                <p:cTn id="65" presetID="3" presetClass="exit" presetSubtype="10" fill="hold" nodeType="clickEffect">
+                                  <p:stCondLst>
+                                    <p:cond delay="0"/>
+                                  </p:stCondLst>
+                                  <p:childTnLst>
+                                    <p:animEffect transition="out" filter="blinds(horizontal)">
+                                      <p:cBhvr>
+                                        <p:cTn id="66" dur="500"/>
+                                        <p:tgtEl>
+                                          <p:spTgt spid="68"/>
+                                        </p:tgtEl>
+                                      </p:cBhvr>
+                                    </p:animEffect>
+                                    <p:set>
+                                      <p:cBhvr>
+                                        <p:cTn id="67" dur="1" fill="hold">
+                                          <p:stCondLst>
+                                            <p:cond delay="499"/>
+                                          </p:stCondLst>
+                                        </p:cTn>
+                                        <p:tgtEl>
+                                          <p:spTgt spid="68"/>
+                                        </p:tgtEl>
+                                        <p:attrNameLst>
+                                          <p:attrName>style.visibility</p:attrName>
+                                        </p:attrNameLst>
+                                      </p:cBhvr>
+                                      <p:to>
+                                        <p:strVal val="hidden"/>
+                                      </p:to>
+                                    </p:set>
+                                  </p:childTnLst>
+                                </p:cTn>
+                              </p:par>
+                              <p:par>
+                                <p:cTn id="68" presetID="3" presetClass="exit" presetSubtype="10" fill="hold" grpId="1" nodeType="withEffect">
+                                  <p:stCondLst>
+                                    <p:cond delay="0"/>
+                                  </p:stCondLst>
+                                  <p:childTnLst>
+                                    <p:animEffect transition="out" filter="blinds(horizontal)">
+                                      <p:cBhvr>
+                                        <p:cTn id="69" dur="500"/>
+                                        <p:tgtEl>
+                                          <p:spTgt spid="44"/>
+                                        </p:tgtEl>
+                                      </p:cBhvr>
+                                    </p:animEffect>
+                                    <p:set>
+                                      <p:cBhvr>
+                                        <p:cTn id="70" dur="1" fill="hold">
+                                          <p:stCondLst>
+                                            <p:cond delay="499"/>
+                                          </p:stCondLst>
+                                        </p:cTn>
+                                        <p:tgtEl>
+                                          <p:spTgt spid="44"/>
+                                        </p:tgtEl>
+                                        <p:attrNameLst>
+                                          <p:attrName>style.visibility</p:attrName>
+                                        </p:attrNameLst>
+                                      </p:cBhvr>
+                                      <p:to>
+                                        <p:strVal val="hidden"/>
+                                      </p:to>
+                                    </p:set>
+                                  </p:childTnLst>
+                                </p:cTn>
+                              </p:par>
+                              <p:par>
+                                <p:cTn id="71" presetID="3" presetClass="exit" presetSubtype="10" fill="hold" nodeType="withEffect">
+                                  <p:stCondLst>
+                                    <p:cond delay="0"/>
+                                  </p:stCondLst>
+                                  <p:childTnLst>
+                                    <p:animEffect transition="out" filter="blinds(horizontal)">
+                                      <p:cBhvr>
+                                        <p:cTn id="72" dur="500"/>
+                                        <p:tgtEl>
+                                          <p:spTgt spid="69"/>
+                                        </p:tgtEl>
+                                      </p:cBhvr>
+                                    </p:animEffect>
+                                    <p:set>
+                                      <p:cBhvr>
+                                        <p:cTn id="73" dur="1" fill="hold">
+                                          <p:stCondLst>
+                                            <p:cond delay="499"/>
+                                          </p:stCondLst>
+                                        </p:cTn>
+                                        <p:tgtEl>
+                                          <p:spTgt spid="69"/>
+                                        </p:tgtEl>
+                                        <p:attrNameLst>
+                                          <p:attrName>style.visibility</p:attrName>
+                                        </p:attrNameLst>
+                                      </p:cBhvr>
+                                      <p:to>
+                                        <p:strVal val="hidden"/>
+                                      </p:to>
+                                    </p:set>
+                                  </p:childTnLst>
+                                </p:cTn>
+                              </p:par>
+                              <p:par>
+                                <p:cTn id="74" presetID="1" presetClass="entr" presetSubtype="0" fill="hold" nodeType="withEffect">
+                                  <p:stCondLst>
+                                    <p:cond delay="0"/>
+                                  </p:stCondLst>
+                                  <p:childTnLst>
+                                    <p:set>
+                                      <p:cBhvr>
+                                        <p:cTn id="75" dur="1" fill="hold">
+                                          <p:stCondLst>
+                                            <p:cond delay="0"/>
+                                          </p:stCondLst>
+                                        </p:cTn>
+                                        <p:tgtEl>
+                                          <p:spTgt spid="2"/>
+                                        </p:tgtEl>
+                                        <p:attrNameLst>
+                                          <p:attrName>style.visibility</p:attrName>
+                                        </p:attrNameLst>
+                                      </p:cBhvr>
+                                      <p:to>
+                                        <p:strVal val="visible"/>
+                                      </p:to>
+                                    </p:set>
+                                  </p:childTnLst>
+                                  <p:subTnLst>
+                                    <p:audio>
+                                      <p:cMediaNode>
+                                        <p:cTn display="0" masterRel="sameClick">
+                                          <p:stCondLst>
+                                            <p:cond evt="begin" delay="0">
+                                              <p:tn val="74"/>
                                             </p:cond>
                                           </p:stCondLst>
                                           <p:endCondLst>
@@ -33544,225 +33712,26 @@
                     </p:cTn>
                   </p:par>
                   <p:par>
-                    <p:cTn id="66" fill="hold">
+                    <p:cTn id="76" fill="hold">
                       <p:stCondLst>
                         <p:cond delay="indefinite"/>
                       </p:stCondLst>
                       <p:childTnLst>
                         <p:par>
-                          <p:cTn id="67" fill="hold">
+                          <p:cTn id="77" fill="hold">
                             <p:stCondLst>
                               <p:cond delay="0"/>
                             </p:stCondLst>
                             <p:childTnLst>
                               <p:par>
-                                <p:cTn id="68" presetID="3" presetClass="exit" presetSubtype="10" fill="hold" nodeType="clickEffect">
-                                  <p:stCondLst>
-                                    <p:cond delay="0"/>
-                                  </p:stCondLst>
-                                  <p:childTnLst>
-                                    <p:animEffect transition="out" filter="blinds(horizontal)">
-                                      <p:cBhvr>
-                                        <p:cTn id="69" dur="500"/>
-                                        <p:tgtEl>
-                                          <p:spTgt spid="68"/>
-                                        </p:tgtEl>
-                                      </p:cBhvr>
-                                    </p:animEffect>
-                                    <p:set>
-                                      <p:cBhvr>
-                                        <p:cTn id="70" dur="1" fill="hold">
-                                          <p:stCondLst>
-                                            <p:cond delay="499"/>
-                                          </p:stCondLst>
-                                        </p:cTn>
-                                        <p:tgtEl>
-                                          <p:spTgt spid="68"/>
-                                        </p:tgtEl>
-                                        <p:attrNameLst>
-                                          <p:attrName>style.visibility</p:attrName>
-                                        </p:attrNameLst>
-                                      </p:cBhvr>
-                                      <p:to>
-                                        <p:strVal val="hidden"/>
-                                      </p:to>
-                                    </p:set>
-                                  </p:childTnLst>
-                                </p:cTn>
-                              </p:par>
-                              <p:par>
-                                <p:cTn id="71" presetID="3" presetClass="exit" presetSubtype="10" fill="hold" grpId="1" nodeType="withEffect">
-                                  <p:stCondLst>
-                                    <p:cond delay="0"/>
-                                  </p:stCondLst>
-                                  <p:childTnLst>
-                                    <p:animEffect transition="out" filter="blinds(horizontal)">
-                                      <p:cBhvr>
-                                        <p:cTn id="72" dur="500"/>
-                                        <p:tgtEl>
-                                          <p:spTgt spid="44"/>
-                                        </p:tgtEl>
-                                      </p:cBhvr>
-                                    </p:animEffect>
-                                    <p:set>
-                                      <p:cBhvr>
-                                        <p:cTn id="73" dur="1" fill="hold">
-                                          <p:stCondLst>
-                                            <p:cond delay="499"/>
-                                          </p:stCondLst>
-                                        </p:cTn>
-                                        <p:tgtEl>
-                                          <p:spTgt spid="44"/>
-                                        </p:tgtEl>
-                                        <p:attrNameLst>
-                                          <p:attrName>style.visibility</p:attrName>
-                                        </p:attrNameLst>
-                                      </p:cBhvr>
-                                      <p:to>
-                                        <p:strVal val="hidden"/>
-                                      </p:to>
-                                    </p:set>
-                                  </p:childTnLst>
-                                </p:cTn>
-                              </p:par>
-                              <p:par>
-                                <p:cTn id="74" presetID="3" presetClass="exit" presetSubtype="10" fill="hold" nodeType="withEffect">
-                                  <p:stCondLst>
-                                    <p:cond delay="0"/>
-                                  </p:stCondLst>
-                                  <p:childTnLst>
-                                    <p:animEffect transition="out" filter="blinds(horizontal)">
-                                      <p:cBhvr>
-                                        <p:cTn id="75" dur="500"/>
-                                        <p:tgtEl>
-                                          <p:spTgt spid="69"/>
-                                        </p:tgtEl>
-                                      </p:cBhvr>
-                                    </p:animEffect>
-                                    <p:set>
-                                      <p:cBhvr>
-                                        <p:cTn id="76" dur="1" fill="hold">
-                                          <p:stCondLst>
-                                            <p:cond delay="499"/>
-                                          </p:stCondLst>
-                                        </p:cTn>
-                                        <p:tgtEl>
-                                          <p:spTgt spid="69"/>
-                                        </p:tgtEl>
-                                        <p:attrNameLst>
-                                          <p:attrName>style.visibility</p:attrName>
-                                        </p:attrNameLst>
-                                      </p:cBhvr>
-                                      <p:to>
-                                        <p:strVal val="hidden"/>
-                                      </p:to>
-                                    </p:set>
-                                  </p:childTnLst>
-                                </p:cTn>
-                              </p:par>
-                            </p:childTnLst>
-                          </p:cTn>
-                        </p:par>
-                      </p:childTnLst>
-                    </p:cTn>
-                  </p:par>
-                  <p:par>
-                    <p:cTn id="77" fill="hold">
-                      <p:stCondLst>
-                        <p:cond delay="indefinite"/>
-                      </p:stCondLst>
-                      <p:childTnLst>
-                        <p:par>
-                          <p:cTn id="78" fill="hold">
-                            <p:stCondLst>
-                              <p:cond delay="0"/>
-                            </p:stCondLst>
-                            <p:childTnLst>
-                              <p:par>
-                                <p:cTn id="79" presetID="22" presetClass="entr" presetSubtype="8" fill="hold" nodeType="clickEffect">
+                                <p:cTn id="78" presetID="37" presetClass="entr" presetSubtype="0" fill="hold" nodeType="clickEffect">
                                   <p:stCondLst>
                                     <p:cond delay="0"/>
                                   </p:stCondLst>
                                   <p:childTnLst>
                                     <p:set>
                                       <p:cBhvr>
-                                        <p:cTn id="80" dur="1" fill="hold">
-                                          <p:stCondLst>
-                                            <p:cond delay="0"/>
-                                          </p:stCondLst>
-                                        </p:cTn>
-                                        <p:tgtEl>
-                                          <p:spTgt spid="72"/>
-                                        </p:tgtEl>
-                                        <p:attrNameLst>
-                                          <p:attrName>style.visibility</p:attrName>
-                                        </p:attrNameLst>
-                                      </p:cBhvr>
-                                      <p:to>
-                                        <p:strVal val="visible"/>
-                                      </p:to>
-                                    </p:set>
-                                    <p:animEffect transition="in" filter="wipe(left)">
-                                      <p:cBhvr>
-                                        <p:cTn id="81" dur="500"/>
-                                        <p:tgtEl>
-                                          <p:spTgt spid="72"/>
-                                        </p:tgtEl>
-                                      </p:cBhvr>
-                                    </p:animEffect>
-                                  </p:childTnLst>
-                                  <p:subTnLst>
-                                    <p:audio>
-                                      <p:cMediaNode>
-                                        <p:cTn display="0" masterRel="sameClick">
-                                          <p:stCondLst>
-                                            <p:cond evt="begin" delay="0">
-                                              <p:tn val="79"/>
-                                            </p:cond>
-                                          </p:stCondLst>
-                                          <p:endCondLst>
-                                            <p:cond evt="onStopAudio" delay="0">
-                                              <p:tgtEl>
-                                                <p:sldTgt/>
-                                              </p:tgtEl>
-                                            </p:cond>
-                                          </p:endCondLst>
-                                        </p:cTn>
-                                        <p:tgtEl>
-                                          <p:sndTgt r:embed="rId3" name="suction.wav"/>
-                                        </p:tgtEl>
-                                      </p:cMediaNode>
-                                    </p:audio>
-                                  </p:subTnLst>
-                                </p:cTn>
-                              </p:par>
-                            </p:childTnLst>
-                          </p:cTn>
-                        </p:par>
-                      </p:childTnLst>
-                    </p:cTn>
-                  </p:par>
-                  <p:par>
-                    <p:cTn id="82" fill="hold">
-                      <p:stCondLst>
-                        <p:cond delay="indefinite"/>
-                      </p:stCondLst>
-                      <p:childTnLst>
-                        <p:par>
-                          <p:cTn id="83" fill="hold">
-                            <p:stCondLst>
-                              <p:cond delay="0"/>
-                            </p:stCondLst>
-                            <p:childTnLst>
-                              <p:par>
-                                <p:cTn id="84" presetID="37" presetClass="entr" presetSubtype="0" fill="hold" nodeType="clickEffect">
-                                  <p:stCondLst>
-                                    <p:cond delay="0"/>
-                                  </p:stCondLst>
-                                  <p:childTnLst>
-                                    <p:set>
-                                      <p:cBhvr>
-                                        <p:cTn id="85" dur="1" fill="hold">
+                                        <p:cTn id="79" dur="1" fill="hold">
                                           <p:stCondLst>
                                             <p:cond delay="0"/>
                                           </p:stCondLst>
@@ -33780,7 +33749,7 @@
                                     </p:set>
                                     <p:animEffect transition="in" filter="fade">
                                       <p:cBhvr>
-                                        <p:cTn id="86" dur="1000"/>
+                                        <p:cTn id="80" dur="1000"/>
                                         <p:tgtEl>
                                           <p:spTgt spid="76"/>
                                         </p:tgtEl>
@@ -33788,7 +33757,7 @@
                                     </p:animEffect>
                                     <p:anim calcmode="lin" valueType="num">
                                       <p:cBhvr>
-                                        <p:cTn id="87" dur="1000" fill="hold"/>
+                                        <p:cTn id="81" dur="1000" fill="hold"/>
                                         <p:tgtEl>
                                           <p:spTgt spid="76"/>
                                         </p:tgtEl>
@@ -33811,7 +33780,7 @@
                                     </p:anim>
                                     <p:anim calcmode="lin" valueType="num">
                                       <p:cBhvr>
-                                        <p:cTn id="88" dur="900" decel="100000" fill="hold"/>
+                                        <p:cTn id="82" dur="900" decel="100000" fill="hold"/>
                                         <p:tgtEl>
                                           <p:spTgt spid="76"/>
                                         </p:tgtEl>
@@ -33834,7 +33803,7 @@
                                     </p:anim>
                                     <p:anim calcmode="lin" valueType="num">
                                       <p:cBhvr>
-                                        <p:cTn id="89" dur="100" accel="100000" fill="hold">
+                                        <p:cTn id="83" dur="100" accel="100000" fill="hold">
                                           <p:stCondLst>
                                             <p:cond delay="900"/>
                                           </p:stCondLst>
@@ -33863,14 +33832,14 @@
                                 </p:cTn>
                               </p:par>
                               <p:par>
-                                <p:cTn id="90" presetID="37" presetClass="entr" presetSubtype="0" fill="hold" grpId="0" nodeType="withEffect">
+                                <p:cTn id="84" presetID="37" presetClass="entr" presetSubtype="0" fill="hold" grpId="0" nodeType="withEffect">
                                   <p:stCondLst>
                                     <p:cond delay="0"/>
                                   </p:stCondLst>
                                   <p:childTnLst>
                                     <p:set>
                                       <p:cBhvr>
-                                        <p:cTn id="91" dur="1" fill="hold">
+                                        <p:cTn id="85" dur="1" fill="hold">
                                           <p:stCondLst>
                                             <p:cond delay="0"/>
                                           </p:stCondLst>
@@ -33888,7 +33857,7 @@
                                     </p:set>
                                     <p:animEffect transition="in" filter="fade">
                                       <p:cBhvr>
-                                        <p:cTn id="92" dur="1000"/>
+                                        <p:cTn id="86" dur="1000"/>
                                         <p:tgtEl>
                                           <p:spTgt spid="77"/>
                                         </p:tgtEl>
@@ -33896,7 +33865,7 @@
                                     </p:animEffect>
                                     <p:anim calcmode="lin" valueType="num">
                                       <p:cBhvr>
-                                        <p:cTn id="93" dur="1000" fill="hold"/>
+                                        <p:cTn id="87" dur="1000" fill="hold"/>
                                         <p:tgtEl>
                                           <p:spTgt spid="77"/>
                                         </p:tgtEl>
@@ -33919,7 +33888,7 @@
                                     </p:anim>
                                     <p:anim calcmode="lin" valueType="num">
                                       <p:cBhvr>
-                                        <p:cTn id="94" dur="900" decel="100000" fill="hold"/>
+                                        <p:cTn id="88" dur="900" decel="100000" fill="hold"/>
                                         <p:tgtEl>
                                           <p:spTgt spid="77"/>
                                         </p:tgtEl>
@@ -33942,7 +33911,7 @@
                                     </p:anim>
                                     <p:anim calcmode="lin" valueType="num">
                                       <p:cBhvr>
-                                        <p:cTn id="95" dur="100" accel="100000" fill="hold">
+                                        <p:cTn id="89" dur="100" accel="100000" fill="hold">
                                           <p:stCondLst>
                                             <p:cond delay="900"/>
                                           </p:stCondLst>
@@ -33977,26 +33946,26 @@
                     </p:cTn>
                   </p:par>
                   <p:par>
-                    <p:cTn id="96" fill="hold">
+                    <p:cTn id="90" fill="hold">
                       <p:stCondLst>
                         <p:cond delay="indefinite"/>
                       </p:stCondLst>
                       <p:childTnLst>
                         <p:par>
-                          <p:cTn id="97" fill="hold">
+                          <p:cTn id="91" fill="hold">
                             <p:stCondLst>
                               <p:cond delay="0"/>
                             </p:stCondLst>
                             <p:childTnLst>
                               <p:par>
-                                <p:cTn id="98" presetID="3" presetClass="entr" presetSubtype="10" fill="hold" grpId="0" nodeType="clickEffect">
+                                <p:cTn id="92" presetID="3" presetClass="entr" presetSubtype="10" fill="hold" grpId="0" nodeType="clickEffect">
                                   <p:stCondLst>
                                     <p:cond delay="0"/>
                                   </p:stCondLst>
                                   <p:childTnLst>
                                     <p:set>
                                       <p:cBhvr>
-                                        <p:cTn id="99" dur="1" fill="hold">
+                                        <p:cTn id="93" dur="1" fill="hold">
                                           <p:stCondLst>
                                             <p:cond delay="0"/>
                                           </p:stCondLst>
@@ -34014,7 +33983,7 @@
                                     </p:set>
                                     <p:animEffect transition="in" filter="blinds(horizontal)">
                                       <p:cBhvr>
-                                        <p:cTn id="100" dur="500"/>
+                                        <p:cTn id="94" dur="500"/>
                                         <p:tgtEl>
                                           <p:spTgt spid="75"/>
                                         </p:tgtEl>
@@ -34030,26 +33999,26 @@
                     </p:cTn>
                   </p:par>
                   <p:par>
-                    <p:cTn id="101" fill="hold">
+                    <p:cTn id="95" fill="hold">
                       <p:stCondLst>
                         <p:cond delay="indefinite"/>
                       </p:stCondLst>
                       <p:childTnLst>
                         <p:par>
-                          <p:cTn id="102" fill="hold">
+                          <p:cTn id="96" fill="hold">
                             <p:stCondLst>
                               <p:cond delay="0"/>
                             </p:stCondLst>
                             <p:childTnLst>
                               <p:par>
-                                <p:cTn id="103" presetID="3" presetClass="entr" presetSubtype="10" fill="hold" grpId="0" nodeType="clickEffect">
+                                <p:cTn id="97" presetID="3" presetClass="entr" presetSubtype="10" fill="hold" grpId="0" nodeType="clickEffect">
                                   <p:stCondLst>
                                     <p:cond delay="0"/>
                                   </p:stCondLst>
                                   <p:childTnLst>
                                     <p:set>
                                       <p:cBhvr>
-                                        <p:cTn id="104" dur="1" fill="hold">
+                                        <p:cTn id="98" dur="1" fill="hold">
                                           <p:stCondLst>
                                             <p:cond delay="0"/>
                                           </p:stCondLst>
@@ -34067,7 +34036,7 @@
                                     </p:set>
                                     <p:animEffect transition="in" filter="blinds(horizontal)">
                                       <p:cBhvr>
-                                        <p:cTn id="105" dur="500"/>
+                                        <p:cTn id="99" dur="500"/>
                                         <p:tgtEl>
                                           <p:spTgt spid="78"/>
                                         </p:tgtEl>

</xml_diff>

<commit_message>
chore: update presentation file
</commit_message>
<xml_diff>
--- a/《平均数》.pptx
+++ b/《平均数》.pptx
@@ -222,7 +222,7 @@
           <a:p>
             <a:fld id="{D2A48B96-639E-45A3-A0BA-2464DFDB1FAA}" type="datetimeFigureOut">
               <a:rPr lang="zh-CN" altLang="en-US" smtClean="0"/>
-              <a:t>2026/4/6</a:t>
+              <a:t>2026/4/8</a:t>
             </a:fld>
             <a:endParaRPr lang="zh-CN" altLang="en-US"/>
           </a:p>
@@ -613,7 +613,7 @@
           <a:p>
             <a:fld id="{115465E4-B37B-4A4B-A30F-C966582A971F}" type="datetimeFigureOut">
               <a:rPr lang="zh-CN" altLang="en-US" smtClean="0"/>
-              <a:t>2026/4/6</a:t>
+              <a:t>2026/4/8</a:t>
             </a:fld>
             <a:endParaRPr lang="zh-CN" altLang="en-US"/>
           </a:p>
@@ -776,7 +776,7 @@
           <a:p>
             <a:fld id="{115465E4-B37B-4A4B-A30F-C966582A971F}" type="datetimeFigureOut">
               <a:rPr lang="zh-CN" altLang="en-US" smtClean="0"/>
-              <a:t>2026/4/6</a:t>
+              <a:t>2026/4/8</a:t>
             </a:fld>
             <a:endParaRPr lang="zh-CN" altLang="en-US"/>
           </a:p>
@@ -949,7 +949,7 @@
           <a:p>
             <a:fld id="{115465E4-B37B-4A4B-A30F-C966582A971F}" type="datetimeFigureOut">
               <a:rPr lang="zh-CN" altLang="en-US" smtClean="0"/>
-              <a:t>2026/4/6</a:t>
+              <a:t>2026/4/8</a:t>
             </a:fld>
             <a:endParaRPr lang="zh-CN" altLang="en-US"/>
           </a:p>
@@ -1112,7 +1112,7 @@
           <a:p>
             <a:fld id="{115465E4-B37B-4A4B-A30F-C966582A971F}" type="datetimeFigureOut">
               <a:rPr lang="zh-CN" altLang="en-US" smtClean="0"/>
-              <a:t>2026/4/6</a:t>
+              <a:t>2026/4/8</a:t>
             </a:fld>
             <a:endParaRPr lang="zh-CN" altLang="en-US"/>
           </a:p>
@@ -1352,7 +1352,7 @@
           <a:p>
             <a:fld id="{115465E4-B37B-4A4B-A30F-C966582A971F}" type="datetimeFigureOut">
               <a:rPr lang="zh-CN" altLang="en-US" smtClean="0"/>
-              <a:t>2026/4/6</a:t>
+              <a:t>2026/4/8</a:t>
             </a:fld>
             <a:endParaRPr lang="zh-CN" altLang="en-US"/>
           </a:p>
@@ -1576,7 +1576,7 @@
           <a:p>
             <a:fld id="{115465E4-B37B-4A4B-A30F-C966582A971F}" type="datetimeFigureOut">
               <a:rPr lang="zh-CN" altLang="en-US" smtClean="0"/>
-              <a:t>2026/4/6</a:t>
+              <a:t>2026/4/8</a:t>
             </a:fld>
             <a:endParaRPr lang="zh-CN" altLang="en-US"/>
           </a:p>
@@ -1935,7 +1935,7 @@
           <a:p>
             <a:fld id="{115465E4-B37B-4A4B-A30F-C966582A971F}" type="datetimeFigureOut">
               <a:rPr lang="zh-CN" altLang="en-US" smtClean="0"/>
-              <a:t>2026/4/6</a:t>
+              <a:t>2026/4/8</a:t>
             </a:fld>
             <a:endParaRPr lang="zh-CN" altLang="en-US"/>
           </a:p>
@@ -2047,7 +2047,7 @@
           <a:p>
             <a:fld id="{115465E4-B37B-4A4B-A30F-C966582A971F}" type="datetimeFigureOut">
               <a:rPr lang="zh-CN" altLang="en-US" smtClean="0"/>
-              <a:t>2026/4/6</a:t>
+              <a:t>2026/4/8</a:t>
             </a:fld>
             <a:endParaRPr lang="zh-CN" altLang="en-US"/>
           </a:p>
@@ -2137,7 +2137,7 @@
           <a:p>
             <a:fld id="{115465E4-B37B-4A4B-A30F-C966582A971F}" type="datetimeFigureOut">
               <a:rPr lang="zh-CN" altLang="en-US" smtClean="0"/>
-              <a:t>2026/4/6</a:t>
+              <a:t>2026/4/8</a:t>
             </a:fld>
             <a:endParaRPr lang="zh-CN" altLang="en-US"/>
           </a:p>
@@ -2407,7 +2407,7 @@
           <a:p>
             <a:fld id="{115465E4-B37B-4A4B-A30F-C966582A971F}" type="datetimeFigureOut">
               <a:rPr lang="zh-CN" altLang="en-US" smtClean="0"/>
-              <a:t>2026/4/6</a:t>
+              <a:t>2026/4/8</a:t>
             </a:fld>
             <a:endParaRPr lang="zh-CN" altLang="en-US"/>
           </a:p>
@@ -2654,7 +2654,7 @@
           <a:p>
             <a:fld id="{115465E4-B37B-4A4B-A30F-C966582A971F}" type="datetimeFigureOut">
               <a:rPr lang="zh-CN" altLang="en-US" smtClean="0"/>
-              <a:t>2026/4/6</a:t>
+              <a:t>2026/4/8</a:t>
             </a:fld>
             <a:endParaRPr lang="zh-CN" altLang="en-US"/>
           </a:p>
@@ -2866,7 +2866,7 @@
           <a:p>
             <a:fld id="{115465E4-B37B-4A4B-A30F-C966582A971F}" type="datetimeFigureOut">
               <a:rPr lang="zh-CN" altLang="en-US" smtClean="0"/>
-              <a:t>2026/4/6</a:t>
+              <a:t>2026/4/8</a:t>
             </a:fld>
             <a:endParaRPr lang="zh-CN" altLang="en-US"/>
           </a:p>
@@ -4289,18 +4289,6 @@
   <p:clrMapOvr>
     <a:masterClrMapping/>
   </p:clrMapOvr>
-  <mc:AlternateContent xmlns:mc="http://schemas.openxmlformats.org/markup-compatibility/2006" xmlns:p15="http://schemas.microsoft.com/office/powerpoint/2012/main">
-    <mc:Choice Requires="p15">
-      <p:transition xmlns:p14="http://schemas.microsoft.com/office/powerpoint/2010/main" spd="slow" p14:dur="1250">
-        <p15:prstTrans prst="airplane"/>
-      </p:transition>
-    </mc:Choice>
-    <mc:Fallback xmlns="">
-      <p:transition spd="slow">
-        <p:fade/>
-      </p:transition>
-    </mc:Fallback>
-  </mc:AlternateContent>
 </p:sld>
 </file>
 
@@ -4768,18 +4756,6 @@
   <p:clrMapOvr>
     <a:masterClrMapping/>
   </p:clrMapOvr>
-  <mc:AlternateContent xmlns:mc="http://schemas.openxmlformats.org/markup-compatibility/2006" xmlns:p14="http://schemas.microsoft.com/office/powerpoint/2010/main">
-    <mc:Choice Requires="p14">
-      <p:transition spd="slow" p14:dur="1200">
-        <p14:prism/>
-      </p:transition>
-    </mc:Choice>
-    <mc:Fallback xmlns="">
-      <p:transition spd="slow">
-        <p:fade/>
-      </p:transition>
-    </mc:Fallback>
-  </mc:AlternateContent>
 </p:sld>
 </file>
 
@@ -5309,18 +5285,6 @@
   <p:clrMapOvr>
     <a:masterClrMapping/>
   </p:clrMapOvr>
-  <mc:AlternateContent xmlns:mc="http://schemas.openxmlformats.org/markup-compatibility/2006" xmlns:p14="http://schemas.microsoft.com/office/powerpoint/2010/main">
-    <mc:Choice Requires="p14">
-      <p:transition spd="slow" p14:dur="1200">
-        <p14:prism/>
-      </p:transition>
-    </mc:Choice>
-    <mc:Fallback xmlns="">
-      <p:transition spd="slow">
-        <p:fade/>
-      </p:transition>
-    </mc:Fallback>
-  </mc:AlternateContent>
   <p:timing>
     <p:tnLst>
       <p:par>
@@ -11255,7 +11219,7 @@
           <p:nvPr/>
         </p:nvPicPr>
         <p:blipFill>
-          <a:blip r:embed="rId4" cstate="screen">
+          <a:blip r:embed="rId3" cstate="screen">
             <a:extLst>
               <a:ext uri="{28A0092B-C50C-407E-A947-70E740481C1C}">
                 <a14:useLocalDpi xmlns:a14="http://schemas.microsoft.com/office/drawing/2010/main" val="0"/>
@@ -11329,7 +11293,7 @@
           <p:nvPr/>
         </p:nvPicPr>
         <p:blipFill>
-          <a:blip r:embed="rId5" cstate="screen">
+          <a:blip r:embed="rId4" cstate="screen">
             <a:extLst>
               <a:ext uri="{28A0092B-C50C-407E-A947-70E740481C1C}">
                 <a14:useLocalDpi xmlns:a14="http://schemas.microsoft.com/office/drawing/2010/main" val="0"/>
@@ -11403,7 +11367,7 @@
           <p:nvPr/>
         </p:nvPicPr>
         <p:blipFill>
-          <a:blip r:embed="rId4" cstate="screen">
+          <a:blip r:embed="rId3" cstate="screen">
             <a:extLst>
               <a:ext uri="{28A0092B-C50C-407E-A947-70E740481C1C}">
                 <a14:useLocalDpi xmlns:a14="http://schemas.microsoft.com/office/drawing/2010/main" val="0"/>
@@ -12617,7 +12581,7 @@
           <p:nvPr/>
         </p:nvPicPr>
         <p:blipFill>
-          <a:blip r:embed="rId6"/>
+          <a:blip r:embed="rId5"/>
           <a:stretch>
             <a:fillRect/>
           </a:stretch>
@@ -12641,7 +12605,7 @@
           <p:nvPr/>
         </p:nvPicPr>
         <p:blipFill>
-          <a:blip r:embed="rId7"/>
+          <a:blip r:embed="rId6"/>
           <a:stretch>
             <a:fillRect/>
           </a:stretch>
@@ -12671,7 +12635,7 @@
           <p:nvPr/>
         </p:nvPicPr>
         <p:blipFill>
-          <a:blip r:embed="rId6"/>
+          <a:blip r:embed="rId5"/>
           <a:stretch>
             <a:fillRect/>
           </a:stretch>
@@ -12701,7 +12665,7 @@
           <p:nvPr/>
         </p:nvPicPr>
         <p:blipFill>
-          <a:blip r:embed="rId6"/>
+          <a:blip r:embed="rId5"/>
           <a:stretch>
             <a:fillRect/>
           </a:stretch>
@@ -12731,7 +12695,7 @@
           <p:nvPr/>
         </p:nvPicPr>
         <p:blipFill>
-          <a:blip r:embed="rId6"/>
+          <a:blip r:embed="rId5"/>
           <a:stretch>
             <a:fillRect/>
           </a:stretch>
@@ -12761,7 +12725,7 @@
           <p:nvPr/>
         </p:nvPicPr>
         <p:blipFill>
-          <a:blip r:embed="rId6"/>
+          <a:blip r:embed="rId5"/>
           <a:stretch>
             <a:fillRect/>
           </a:stretch>
@@ -12791,7 +12755,7 @@
           <p:nvPr/>
         </p:nvPicPr>
         <p:blipFill>
-          <a:blip r:embed="rId6"/>
+          <a:blip r:embed="rId5"/>
           <a:stretch>
             <a:fillRect/>
           </a:stretch>
@@ -14536,29 +14500,6 @@
                                       </p:cBhvr>
                                     </p:animEffect>
                                   </p:childTnLst>
-                                  <p:subTnLst>
-                                    <p:audio>
-                                      <p:cMediaNode>
-                                        <p:cTn display="0" masterRel="sameClick">
-                                          <p:stCondLst>
-                                            <p:cond evt="begin" delay="0">
-                                              <p:tn val="123"/>
-                                            </p:cond>
-                                          </p:stCondLst>
-                                          <p:endCondLst>
-                                            <p:cond evt="onStopAudio" delay="0">
-                                              <p:tgtEl>
-                                                <p:sldTgt/>
-                                              </p:tgtEl>
-                                            </p:cond>
-                                          </p:endCondLst>
-                                        </p:cTn>
-                                        <p:tgtEl>
-                                          <p:sndTgt r:embed="rId3" name="suction.wav"/>
-                                        </p:tgtEl>
-                                      </p:cMediaNode>
-                                    </p:audio>
-                                  </p:subTnLst>
                                 </p:cTn>
                               </p:par>
                             </p:childTnLst>
@@ -20802,7 +20743,7 @@
           <p:nvPr/>
         </p:nvPicPr>
         <p:blipFill>
-          <a:blip r:embed="rId4" cstate="screen">
+          <a:blip r:embed="rId3" cstate="screen">
             <a:extLst>
               <a:ext uri="{28A0092B-C50C-407E-A947-70E740481C1C}">
                 <a14:useLocalDpi xmlns:a14="http://schemas.microsoft.com/office/drawing/2010/main" val="0"/>
@@ -20876,7 +20817,7 @@
           <p:nvPr/>
         </p:nvPicPr>
         <p:blipFill>
-          <a:blip r:embed="rId5" cstate="screen">
+          <a:blip r:embed="rId4" cstate="screen">
             <a:extLst>
               <a:ext uri="{28A0092B-C50C-407E-A947-70E740481C1C}">
                 <a14:useLocalDpi xmlns:a14="http://schemas.microsoft.com/office/drawing/2010/main" val="0"/>
@@ -20950,7 +20891,7 @@
           <p:nvPr/>
         </p:nvPicPr>
         <p:blipFill>
-          <a:blip r:embed="rId4" cstate="screen">
+          <a:blip r:embed="rId3" cstate="screen">
             <a:extLst>
               <a:ext uri="{28A0092B-C50C-407E-A947-70E740481C1C}">
                 <a14:useLocalDpi xmlns:a14="http://schemas.microsoft.com/office/drawing/2010/main" val="0"/>
@@ -22189,7 +22130,7 @@
           <p:nvPr/>
         </p:nvPicPr>
         <p:blipFill>
-          <a:blip r:embed="rId6"/>
+          <a:blip r:embed="rId5"/>
           <a:stretch>
             <a:fillRect/>
           </a:stretch>
@@ -22628,7 +22569,7 @@
           <p:nvPr/>
         </p:nvPicPr>
         <p:blipFill>
-          <a:blip r:embed="rId7"/>
+          <a:blip r:embed="rId6"/>
           <a:stretch>
             <a:fillRect/>
           </a:stretch>
@@ -22658,7 +22599,7 @@
           <p:nvPr/>
         </p:nvPicPr>
         <p:blipFill>
-          <a:blip r:embed="rId7"/>
+          <a:blip r:embed="rId6"/>
           <a:stretch>
             <a:fillRect/>
           </a:stretch>
@@ -22688,7 +22629,7 @@
           <p:nvPr/>
         </p:nvPicPr>
         <p:blipFill>
-          <a:blip r:embed="rId7"/>
+          <a:blip r:embed="rId6"/>
           <a:stretch>
             <a:fillRect/>
           </a:stretch>
@@ -22718,7 +22659,7 @@
           <p:nvPr/>
         </p:nvPicPr>
         <p:blipFill>
-          <a:blip r:embed="rId7"/>
+          <a:blip r:embed="rId6"/>
           <a:stretch>
             <a:fillRect/>
           </a:stretch>
@@ -23003,29 +22944,6 @@
                                       </p:cBhvr>
                                     </p:animEffect>
                                   </p:childTnLst>
-                                  <p:subTnLst>
-                                    <p:audio>
-                                      <p:cMediaNode>
-                                        <p:cTn display="0" masterRel="sameClick">
-                                          <p:stCondLst>
-                                            <p:cond evt="begin" delay="0">
-                                              <p:tn val="25"/>
-                                            </p:cond>
-                                          </p:stCondLst>
-                                          <p:endCondLst>
-                                            <p:cond evt="onStopAudio" delay="0">
-                                              <p:tgtEl>
-                                                <p:sldTgt/>
-                                              </p:tgtEl>
-                                            </p:cond>
-                                          </p:endCondLst>
-                                        </p:cTn>
-                                        <p:tgtEl>
-                                          <p:sndTgt r:embed="rId3" name="suction.wav"/>
-                                        </p:tgtEl>
-                                      </p:cMediaNode>
-                                    </p:audio>
-                                  </p:subTnLst>
                                 </p:cTn>
                               </p:par>
                             </p:childTnLst>
@@ -29912,7 +29830,7 @@
           <p:nvPr/>
         </p:nvPicPr>
         <p:blipFill>
-          <a:blip r:embed="rId4" cstate="screen">
+          <a:blip r:embed="rId3" cstate="screen">
             <a:extLst>
               <a:ext uri="{28A0092B-C50C-407E-A947-70E740481C1C}">
                 <a14:useLocalDpi xmlns:a14="http://schemas.microsoft.com/office/drawing/2010/main" val="0"/>
@@ -29986,7 +29904,7 @@
           <p:nvPr/>
         </p:nvPicPr>
         <p:blipFill>
-          <a:blip r:embed="rId5" cstate="screen">
+          <a:blip r:embed="rId4" cstate="screen">
             <a:extLst>
               <a:ext uri="{28A0092B-C50C-407E-A947-70E740481C1C}">
                 <a14:useLocalDpi xmlns:a14="http://schemas.microsoft.com/office/drawing/2010/main" val="0"/>
@@ -30060,7 +29978,7 @@
           <p:nvPr/>
         </p:nvPicPr>
         <p:blipFill>
-          <a:blip r:embed="rId4" cstate="screen">
+          <a:blip r:embed="rId3" cstate="screen">
             <a:extLst>
               <a:ext uri="{28A0092B-C50C-407E-A947-70E740481C1C}">
                 <a14:useLocalDpi xmlns:a14="http://schemas.microsoft.com/office/drawing/2010/main" val="0"/>
@@ -31560,7 +31478,7 @@
           <p:nvPr/>
         </p:nvPicPr>
         <p:blipFill>
-          <a:blip r:embed="rId6"/>
+          <a:blip r:embed="rId5"/>
           <a:stretch>
             <a:fillRect/>
           </a:stretch>
@@ -31590,7 +31508,7 @@
           <p:nvPr/>
         </p:nvPicPr>
         <p:blipFill>
-          <a:blip r:embed="rId6"/>
+          <a:blip r:embed="rId5"/>
           <a:stretch>
             <a:fillRect/>
           </a:stretch>
@@ -31620,7 +31538,7 @@
           <p:nvPr/>
         </p:nvPicPr>
         <p:blipFill>
-          <a:blip r:embed="rId6"/>
+          <a:blip r:embed="rId5"/>
           <a:stretch>
             <a:fillRect/>
           </a:stretch>
@@ -31650,14 +31568,14 @@
           <p:nvPr/>
         </p:nvPicPr>
         <p:blipFill>
-          <a:blip r:embed="rId6"/>
+          <a:blip r:embed="rId5"/>
           <a:stretch>
             <a:fillRect/>
           </a:stretch>
         </p:blipFill>
         <p:spPr>
           <a:xfrm>
-            <a:off x="5635289" y="2633116"/>
+            <a:off x="5635289" y="2654382"/>
             <a:ext cx="395416" cy="3820918"/>
           </a:xfrm>
           <a:prstGeom prst="rect">
@@ -32130,7 +32048,7 @@
           <p:nvPr/>
         </p:nvPicPr>
         <p:blipFill>
-          <a:blip r:embed="rId6"/>
+          <a:blip r:embed="rId5"/>
           <a:stretch>
             <a:fillRect/>
           </a:stretch>
@@ -32347,7 +32265,7 @@
           <p:nvPr/>
         </p:nvPicPr>
         <p:blipFill>
-          <a:blip r:embed="rId6"/>
+          <a:blip r:embed="rId5"/>
           <a:stretch>
             <a:fillRect/>
           </a:stretch>
@@ -32450,8 +32368,8 @@
         </p:nvGrpSpPr>
         <p:grpSpPr>
           <a:xfrm>
-            <a:off x="2984191" y="3668645"/>
-            <a:ext cx="5432425" cy="521970"/>
+            <a:off x="2984190" y="3668645"/>
+            <a:ext cx="5432424" cy="521970"/>
             <a:chOff x="7193" y="3503"/>
             <a:chExt cx="8122" cy="822"/>
           </a:xfrm>
@@ -32466,6 +32384,7 @@
               </a:extLst>
             </p:cNvPr>
             <p:cNvCxnSpPr>
+              <a:cxnSpLocks/>
               <a:endCxn id="7" idx="1"/>
             </p:cNvCxnSpPr>
             <p:nvPr/>
@@ -32644,29 +32563,6 @@
                                       </p:cBhvr>
                                     </p:animEffect>
                                   </p:childTnLst>
-                                  <p:subTnLst>
-                                    <p:audio>
-                                      <p:cMediaNode>
-                                        <p:cTn display="0" masterRel="sameClick">
-                                          <p:stCondLst>
-                                            <p:cond evt="begin" delay="0">
-                                              <p:tn val="5"/>
-                                            </p:cond>
-                                          </p:stCondLst>
-                                          <p:endCondLst>
-                                            <p:cond evt="onStopAudio" delay="0">
-                                              <p:tgtEl>
-                                                <p:sldTgt/>
-                                              </p:tgtEl>
-                                            </p:cond>
-                                          </p:endCondLst>
-                                        </p:cTn>
-                                        <p:tgtEl>
-                                          <p:sndTgt r:embed="rId3" name="suction.wav"/>
-                                        </p:tgtEl>
-                                      </p:cMediaNode>
-                                    </p:audio>
-                                  </p:subTnLst>
                                 </p:cTn>
                               </p:par>
                             </p:childTnLst>
@@ -32989,29 +32885,6 @@
                                       </p:cBhvr>
                                     </p:animEffect>
                                   </p:childTnLst>
-                                  <p:subTnLst>
-                                    <p:audio>
-                                      <p:cMediaNode>
-                                        <p:cTn display="0" masterRel="sameClick">
-                                          <p:stCondLst>
-                                            <p:cond evt="begin" delay="0">
-                                              <p:tn val="27"/>
-                                            </p:cond>
-                                          </p:stCondLst>
-                                          <p:endCondLst>
-                                            <p:cond evt="onStopAudio" delay="0">
-                                              <p:tgtEl>
-                                                <p:sldTgt/>
-                                              </p:tgtEl>
-                                            </p:cond>
-                                          </p:endCondLst>
-                                        </p:cTn>
-                                        <p:tgtEl>
-                                          <p:sndTgt r:embed="rId3" name="suction.wav"/>
-                                        </p:tgtEl>
-                                      </p:cMediaNode>
-                                    </p:audio>
-                                  </p:subTnLst>
                                 </p:cTn>
                               </p:par>
                             </p:childTnLst>
@@ -33162,29 +33035,6 @@
                                       </p:to>
                                     </p:set>
                                   </p:childTnLst>
-                                  <p:subTnLst>
-                                    <p:audio>
-                                      <p:cMediaNode>
-                                        <p:cTn display="0" masterRel="sameClick">
-                                          <p:stCondLst>
-                                            <p:cond evt="begin" delay="0">
-                                              <p:tn val="41"/>
-                                            </p:cond>
-                                          </p:stCondLst>
-                                          <p:endCondLst>
-                                            <p:cond evt="onStopAudio" delay="0">
-                                              <p:tgtEl>
-                                                <p:sldTgt/>
-                                              </p:tgtEl>
-                                            </p:cond>
-                                          </p:endCondLst>
-                                        </p:cTn>
-                                        <p:tgtEl>
-                                          <p:sndTgt r:embed="rId3" name="suction.wav"/>
-                                        </p:tgtEl>
-                                      </p:cMediaNode>
-                                    </p:audio>
-                                  </p:subTnLst>
                                 </p:cTn>
                               </p:par>
                               <p:par>
@@ -33454,29 +33304,6 @@
                                       </p:cBhvr>
                                     </p:animEffect>
                                   </p:childTnLst>
-                                  <p:subTnLst>
-                                    <p:audio>
-                                      <p:cMediaNode>
-                                        <p:cTn display="0" masterRel="sameClick">
-                                          <p:stCondLst>
-                                            <p:cond evt="begin" delay="0">
-                                              <p:tn val="57"/>
-                                            </p:cond>
-                                          </p:stCondLst>
-                                          <p:endCondLst>
-                                            <p:cond evt="onStopAudio" delay="0">
-                                              <p:tgtEl>
-                                                <p:sldTgt/>
-                                              </p:tgtEl>
-                                            </p:cond>
-                                          </p:endCondLst>
-                                        </p:cTn>
-                                        <p:tgtEl>
-                                          <p:sndTgt r:embed="rId3" name="suction.wav"/>
-                                        </p:tgtEl>
-                                      </p:cMediaNode>
-                                    </p:audio>
-                                  </p:subTnLst>
                                 </p:cTn>
                               </p:par>
                               <p:par>
@@ -33662,29 +33489,6 @@
                                       </p:to>
                                     </p:set>
                                   </p:childTnLst>
-                                  <p:subTnLst>
-                                    <p:audio>
-                                      <p:cMediaNode>
-                                        <p:cTn display="0" masterRel="sameClick">
-                                          <p:stCondLst>
-                                            <p:cond evt="begin" delay="0">
-                                              <p:tn val="74"/>
-                                            </p:cond>
-                                          </p:stCondLst>
-                                          <p:endCondLst>
-                                            <p:cond evt="onStopAudio" delay="0">
-                                              <p:tgtEl>
-                                                <p:sldTgt/>
-                                              </p:tgtEl>
-                                            </p:cond>
-                                          </p:endCondLst>
-                                        </p:cTn>
-                                        <p:tgtEl>
-                                          <p:sndTgt r:embed="rId3" name="suction.wav"/>
-                                        </p:tgtEl>
-                                      </p:cMediaNode>
-                                    </p:audio>
-                                  </p:subTnLst>
                                 </p:cTn>
                               </p:par>
                             </p:childTnLst>
@@ -37737,18 +37541,6 @@
   <p:clrMapOvr>
     <a:masterClrMapping/>
   </p:clrMapOvr>
-  <mc:AlternateContent xmlns:mc="http://schemas.openxmlformats.org/markup-compatibility/2006" xmlns:p14="http://schemas.microsoft.com/office/powerpoint/2010/main">
-    <mc:Choice Requires="p14">
-      <p:transition spd="med">
-        <p:newsflash/>
-      </p:transition>
-    </mc:Choice>
-    <mc:Fallback xmlns="">
-      <p:transition spd="med">
-        <p:newsflash/>
-      </p:transition>
-    </mc:Fallback>
-  </mc:AlternateContent>
 </p:sld>
 </file>
 

</xml_diff>

<commit_message>
chore: update presentation file "平均數.pptx
</commit_message>
<xml_diff>
--- a/《平均数》.pptx
+++ b/《平均数》.pptx
@@ -32272,7 +32272,7 @@
         </p:blipFill>
         <p:spPr>
           <a:xfrm>
-            <a:off x="5650080" y="3916973"/>
+            <a:off x="5637723" y="3916973"/>
             <a:ext cx="395416" cy="2545190"/>
           </a:xfrm>
           <a:prstGeom prst="rect">
@@ -32584,7 +32584,7 @@
                             </p:stCondLst>
                             <p:childTnLst>
                               <p:par>
-                                <p:cTn id="10" presetID="37" presetClass="entr" presetSubtype="0" fill="hold" nodeType="clickEffect">
+                                <p:cTn id="10" presetID="22" presetClass="entr" presetSubtype="4" fill="hold" nodeType="clickEffect">
                                   <p:stCondLst>
                                     <p:cond delay="0"/>
                                   </p:stCondLst>
@@ -32607,99 +32607,26 @@
                                         <p:strVal val="visible"/>
                                       </p:to>
                                     </p:set>
-                                    <p:animEffect transition="in" filter="fade">
+                                    <p:animEffect transition="in" filter="wipe(down)">
                                       <p:cBhvr>
-                                        <p:cTn id="12" dur="1000"/>
+                                        <p:cTn id="12" dur="500"/>
                                         <p:tgtEl>
                                           <p:spTgt spid="58"/>
                                         </p:tgtEl>
                                       </p:cBhvr>
                                     </p:animEffect>
-                                    <p:anim calcmode="lin" valueType="num">
-                                      <p:cBhvr>
-                                        <p:cTn id="13" dur="1000" fill="hold"/>
-                                        <p:tgtEl>
-                                          <p:spTgt spid="58"/>
-                                        </p:tgtEl>
-                                        <p:attrNameLst>
-                                          <p:attrName>ppt_x</p:attrName>
-                                        </p:attrNameLst>
-                                      </p:cBhvr>
-                                      <p:tavLst>
-                                        <p:tav tm="0">
-                                          <p:val>
-                                            <p:strVal val="#ppt_x"/>
-                                          </p:val>
-                                        </p:tav>
-                                        <p:tav tm="100000">
-                                          <p:val>
-                                            <p:strVal val="#ppt_x"/>
-                                          </p:val>
-                                        </p:tav>
-                                      </p:tavLst>
-                                    </p:anim>
-                                    <p:anim calcmode="lin" valueType="num">
-                                      <p:cBhvr>
-                                        <p:cTn id="14" dur="900" decel="100000" fill="hold"/>
-                                        <p:tgtEl>
-                                          <p:spTgt spid="58"/>
-                                        </p:tgtEl>
-                                        <p:attrNameLst>
-                                          <p:attrName>ppt_y</p:attrName>
-                                        </p:attrNameLst>
-                                      </p:cBhvr>
-                                      <p:tavLst>
-                                        <p:tav tm="0">
-                                          <p:val>
-                                            <p:strVal val="#ppt_y+1"/>
-                                          </p:val>
-                                        </p:tav>
-                                        <p:tav tm="100000">
-                                          <p:val>
-                                            <p:strVal val="#ppt_y-.03"/>
-                                          </p:val>
-                                        </p:tav>
-                                      </p:tavLst>
-                                    </p:anim>
-                                    <p:anim calcmode="lin" valueType="num">
-                                      <p:cBhvr>
-                                        <p:cTn id="15" dur="100" accel="100000" fill="hold">
-                                          <p:stCondLst>
-                                            <p:cond delay="900"/>
-                                          </p:stCondLst>
-                                        </p:cTn>
-                                        <p:tgtEl>
-                                          <p:spTgt spid="58"/>
-                                        </p:tgtEl>
-                                        <p:attrNameLst>
-                                          <p:attrName>ppt_y</p:attrName>
-                                        </p:attrNameLst>
-                                      </p:cBhvr>
-                                      <p:tavLst>
-                                        <p:tav tm="0">
-                                          <p:val>
-                                            <p:strVal val="#ppt_y-.03"/>
-                                          </p:val>
-                                        </p:tav>
-                                        <p:tav tm="100000">
-                                          <p:val>
-                                            <p:strVal val="#ppt_y"/>
-                                          </p:val>
-                                        </p:tav>
-                                      </p:tavLst>
-                                    </p:anim>
                                   </p:childTnLst>
                                 </p:cTn>
                               </p:par>
                               <p:par>
-                                <p:cTn id="16" presetID="37" presetClass="entr" presetSubtype="0" fill="hold" grpId="0" nodeType="withEffect">
+                                <p:cTn id="13" presetID="22" presetClass="entr" presetSubtype="4" fill="hold" grpId="0" nodeType="withEffect">
                                   <p:stCondLst>
                                     <p:cond delay="0"/>
                                   </p:stCondLst>
                                   <p:childTnLst>
                                     <p:set>
                                       <p:cBhvr>
-                                        <p:cTn id="17" dur="1" fill="hold">
+                                        <p:cTn id="14" dur="1" fill="hold">
                                           <p:stCondLst>
                                             <p:cond delay="0"/>
                                           </p:stCondLst>
@@ -32715,87 +32642,14 @@
                                         <p:strVal val="visible"/>
                                       </p:to>
                                     </p:set>
-                                    <p:animEffect transition="in" filter="fade">
+                                    <p:animEffect transition="in" filter="wipe(down)">
                                       <p:cBhvr>
-                                        <p:cTn id="18" dur="1000"/>
+                                        <p:cTn id="15" dur="500"/>
                                         <p:tgtEl>
                                           <p:spTgt spid="30"/>
                                         </p:tgtEl>
                                       </p:cBhvr>
                                     </p:animEffect>
-                                    <p:anim calcmode="lin" valueType="num">
-                                      <p:cBhvr>
-                                        <p:cTn id="19" dur="1000" fill="hold"/>
-                                        <p:tgtEl>
-                                          <p:spTgt spid="30"/>
-                                        </p:tgtEl>
-                                        <p:attrNameLst>
-                                          <p:attrName>ppt_x</p:attrName>
-                                        </p:attrNameLst>
-                                      </p:cBhvr>
-                                      <p:tavLst>
-                                        <p:tav tm="0">
-                                          <p:val>
-                                            <p:strVal val="#ppt_x"/>
-                                          </p:val>
-                                        </p:tav>
-                                        <p:tav tm="100000">
-                                          <p:val>
-                                            <p:strVal val="#ppt_x"/>
-                                          </p:val>
-                                        </p:tav>
-                                      </p:tavLst>
-                                    </p:anim>
-                                    <p:anim calcmode="lin" valueType="num">
-                                      <p:cBhvr>
-                                        <p:cTn id="20" dur="900" decel="100000" fill="hold"/>
-                                        <p:tgtEl>
-                                          <p:spTgt spid="30"/>
-                                        </p:tgtEl>
-                                        <p:attrNameLst>
-                                          <p:attrName>ppt_y</p:attrName>
-                                        </p:attrNameLst>
-                                      </p:cBhvr>
-                                      <p:tavLst>
-                                        <p:tav tm="0">
-                                          <p:val>
-                                            <p:strVal val="#ppt_y+1"/>
-                                          </p:val>
-                                        </p:tav>
-                                        <p:tav tm="100000">
-                                          <p:val>
-                                            <p:strVal val="#ppt_y-.03"/>
-                                          </p:val>
-                                        </p:tav>
-                                      </p:tavLst>
-                                    </p:anim>
-                                    <p:anim calcmode="lin" valueType="num">
-                                      <p:cBhvr>
-                                        <p:cTn id="21" dur="100" accel="100000" fill="hold">
-                                          <p:stCondLst>
-                                            <p:cond delay="900"/>
-                                          </p:stCondLst>
-                                        </p:cTn>
-                                        <p:tgtEl>
-                                          <p:spTgt spid="30"/>
-                                        </p:tgtEl>
-                                        <p:attrNameLst>
-                                          <p:attrName>ppt_y</p:attrName>
-                                        </p:attrNameLst>
-                                      </p:cBhvr>
-                                      <p:tavLst>
-                                        <p:tav tm="0">
-                                          <p:val>
-                                            <p:strVal val="#ppt_y-.03"/>
-                                          </p:val>
-                                        </p:tav>
-                                        <p:tav tm="100000">
-                                          <p:val>
-                                            <p:strVal val="#ppt_y"/>
-                                          </p:val>
-                                        </p:tav>
-                                      </p:tavLst>
-                                    </p:anim>
                                   </p:childTnLst>
                                 </p:cTn>
                               </p:par>
@@ -32806,26 +32660,26 @@
                     </p:cTn>
                   </p:par>
                   <p:par>
-                    <p:cTn id="22" fill="hold">
+                    <p:cTn id="16" fill="hold">
                       <p:stCondLst>
                         <p:cond delay="indefinite"/>
                       </p:stCondLst>
                       <p:childTnLst>
                         <p:par>
-                          <p:cTn id="23" fill="hold">
+                          <p:cTn id="17" fill="hold">
                             <p:stCondLst>
                               <p:cond delay="0"/>
                             </p:stCondLst>
                             <p:childTnLst>
                               <p:par>
-                                <p:cTn id="24" presetID="3" presetClass="exit" presetSubtype="10" fill="hold" nodeType="clickEffect">
+                                <p:cTn id="18" presetID="3" presetClass="exit" presetSubtype="10" fill="hold" nodeType="clickEffect">
                                   <p:stCondLst>
                                     <p:cond delay="0"/>
                                   </p:stCondLst>
                                   <p:childTnLst>
                                     <p:animEffect transition="out" filter="blinds(horizontal)">
                                       <p:cBhvr>
-                                        <p:cTn id="25" dur="500"/>
+                                        <p:cTn id="19" dur="500"/>
                                         <p:tgtEl>
                                           <p:spTgt spid="49"/>
                                         </p:tgtEl>
@@ -32833,7 +32687,7 @@
                                     </p:animEffect>
                                     <p:set>
                                       <p:cBhvr>
-                                        <p:cTn id="26" dur="1" fill="hold">
+                                        <p:cTn id="20" dur="1" fill="hold">
                                           <p:stCondLst>
                                             <p:cond delay="499"/>
                                           </p:stCondLst>
@@ -32853,14 +32707,14 @@
                                 </p:cTn>
                               </p:par>
                               <p:par>
-                                <p:cTn id="27" presetID="22" presetClass="entr" presetSubtype="8" fill="hold" nodeType="withEffect">
+                                <p:cTn id="21" presetID="22" presetClass="entr" presetSubtype="8" fill="hold" nodeType="withEffect">
                                   <p:stCondLst>
                                     <p:cond delay="0"/>
                                   </p:stCondLst>
                                   <p:childTnLst>
                                     <p:set>
                                       <p:cBhvr>
-                                        <p:cTn id="28" dur="1" fill="hold">
+                                        <p:cTn id="22" dur="1" fill="hold">
                                           <p:stCondLst>
                                             <p:cond delay="0"/>
                                           </p:stCondLst>
@@ -32878,7 +32732,7 @@
                                     </p:set>
                                     <p:animEffect transition="in" filter="wipe(left)">
                                       <p:cBhvr>
-                                        <p:cTn id="29" dur="500"/>
+                                        <p:cTn id="23" dur="500"/>
                                         <p:tgtEl>
                                           <p:spTgt spid="62"/>
                                         </p:tgtEl>
@@ -32894,26 +32748,26 @@
                     </p:cTn>
                   </p:par>
                   <p:par>
-                    <p:cTn id="30" fill="hold">
+                    <p:cTn id="24" fill="hold">
                       <p:stCondLst>
                         <p:cond delay="indefinite"/>
                       </p:stCondLst>
                       <p:childTnLst>
                         <p:par>
-                          <p:cTn id="31" fill="hold">
+                          <p:cTn id="25" fill="hold">
                             <p:stCondLst>
                               <p:cond delay="0"/>
                             </p:stCondLst>
                             <p:childTnLst>
                               <p:par>
-                                <p:cTn id="32" presetID="3" presetClass="exit" presetSubtype="10" fill="hold" nodeType="clickEffect">
+                                <p:cTn id="26" presetID="3" presetClass="exit" presetSubtype="10" fill="hold" nodeType="clickEffect">
                                   <p:stCondLst>
                                     <p:cond delay="0"/>
                                   </p:stCondLst>
                                   <p:childTnLst>
                                     <p:animEffect transition="out" filter="blinds(horizontal)">
                                       <p:cBhvr>
-                                        <p:cTn id="33" dur="500"/>
+                                        <p:cTn id="27" dur="500"/>
                                         <p:tgtEl>
                                           <p:spTgt spid="62"/>
                                         </p:tgtEl>
@@ -32921,7 +32775,7 @@
                                     </p:animEffect>
                                     <p:set>
                                       <p:cBhvr>
-                                        <p:cTn id="34" dur="1" fill="hold">
+                                        <p:cTn id="28" dur="1" fill="hold">
                                           <p:stCondLst>
                                             <p:cond delay="499"/>
                                           </p:stCondLst>
@@ -32941,14 +32795,14 @@
                                 </p:cTn>
                               </p:par>
                               <p:par>
-                                <p:cTn id="35" presetID="3" presetClass="exit" presetSubtype="10" fill="hold" nodeType="withEffect">
+                                <p:cTn id="29" presetID="22" presetClass="exit" presetSubtype="1" fill="hold" nodeType="withEffect">
                                   <p:stCondLst>
                                     <p:cond delay="0"/>
                                   </p:stCondLst>
                                   <p:childTnLst>
-                                    <p:animEffect transition="out" filter="blinds(horizontal)">
+                                    <p:animEffect transition="out" filter="wipe(up)">
                                       <p:cBhvr>
-                                        <p:cTn id="36" dur="500"/>
+                                        <p:cTn id="30" dur="500"/>
                                         <p:tgtEl>
                                           <p:spTgt spid="58"/>
                                         </p:tgtEl>
@@ -32956,7 +32810,7 @@
                                     </p:animEffect>
                                     <p:set>
                                       <p:cBhvr>
-                                        <p:cTn id="37" dur="1" fill="hold">
+                                        <p:cTn id="31" dur="1" fill="hold">
                                           <p:stCondLst>
                                             <p:cond delay="499"/>
                                           </p:stCondLst>
@@ -32976,14 +32830,14 @@
                                 </p:cTn>
                               </p:par>
                               <p:par>
-                                <p:cTn id="38" presetID="3" presetClass="exit" presetSubtype="10" fill="hold" grpId="1" nodeType="withEffect">
+                                <p:cTn id="32" presetID="3" presetClass="exit" presetSubtype="10" fill="hold" grpId="1" nodeType="withEffect">
                                   <p:stCondLst>
                                     <p:cond delay="0"/>
                                   </p:stCondLst>
                                   <p:childTnLst>
                                     <p:animEffect transition="out" filter="blinds(horizontal)">
                                       <p:cBhvr>
-                                        <p:cTn id="39" dur="500"/>
+                                        <p:cTn id="33" dur="500"/>
                                         <p:tgtEl>
                                           <p:spTgt spid="30"/>
                                         </p:tgtEl>
@@ -32991,7 +32845,7 @@
                                     </p:animEffect>
                                     <p:set>
                                       <p:cBhvr>
-                                        <p:cTn id="40" dur="1" fill="hold">
+                                        <p:cTn id="34" dur="1" fill="hold">
                                           <p:stCondLst>
                                             <p:cond delay="499"/>
                                           </p:stCondLst>
@@ -33011,14 +32865,14 @@
                                 </p:cTn>
                               </p:par>
                               <p:par>
-                                <p:cTn id="41" presetID="1" presetClass="entr" presetSubtype="0" fill="hold" nodeType="withEffect">
+                                <p:cTn id="35" presetID="1" presetClass="entr" presetSubtype="0" fill="hold" nodeType="withEffect">
                                   <p:stCondLst>
                                     <p:cond delay="0"/>
                                   </p:stCondLst>
                                   <p:childTnLst>
                                     <p:set>
                                       <p:cBhvr>
-                                        <p:cTn id="42" dur="1" fill="hold">
+                                        <p:cTn id="36" dur="1" fill="hold">
                                           <p:stCondLst>
                                             <p:cond delay="0"/>
                                           </p:stCondLst>
@@ -33038,14 +32892,14 @@
                                 </p:cTn>
                               </p:par>
                               <p:par>
-                                <p:cTn id="43" presetID="37" presetClass="entr" presetSubtype="0" fill="hold" nodeType="withEffect">
+                                <p:cTn id="37" presetID="22" presetClass="entr" presetSubtype="4" fill="hold" nodeType="withEffect">
                                   <p:stCondLst>
                                     <p:cond delay="0"/>
                                   </p:stCondLst>
                                   <p:childTnLst>
                                     <p:set>
                                       <p:cBhvr>
-                                        <p:cTn id="44" dur="1" fill="hold">
+                                        <p:cTn id="38" dur="1" fill="hold">
                                           <p:stCondLst>
                                             <p:cond delay="0"/>
                                           </p:stCondLst>
@@ -33061,99 +32915,26 @@
                                         <p:strVal val="visible"/>
                                       </p:to>
                                     </p:set>
-                                    <p:animEffect transition="in" filter="fade">
+                                    <p:animEffect transition="in" filter="wipe(down)">
                                       <p:cBhvr>
-                                        <p:cTn id="45" dur="1000"/>
+                                        <p:cTn id="39" dur="500"/>
                                         <p:tgtEl>
                                           <p:spTgt spid="68"/>
                                         </p:tgtEl>
                                       </p:cBhvr>
                                     </p:animEffect>
-                                    <p:anim calcmode="lin" valueType="num">
-                                      <p:cBhvr>
-                                        <p:cTn id="46" dur="1000" fill="hold"/>
-                                        <p:tgtEl>
-                                          <p:spTgt spid="68"/>
-                                        </p:tgtEl>
-                                        <p:attrNameLst>
-                                          <p:attrName>ppt_x</p:attrName>
-                                        </p:attrNameLst>
-                                      </p:cBhvr>
-                                      <p:tavLst>
-                                        <p:tav tm="0">
-                                          <p:val>
-                                            <p:strVal val="#ppt_x"/>
-                                          </p:val>
-                                        </p:tav>
-                                        <p:tav tm="100000">
-                                          <p:val>
-                                            <p:strVal val="#ppt_x"/>
-                                          </p:val>
-                                        </p:tav>
-                                      </p:tavLst>
-                                    </p:anim>
-                                    <p:anim calcmode="lin" valueType="num">
-                                      <p:cBhvr>
-                                        <p:cTn id="47" dur="900" decel="100000" fill="hold"/>
-                                        <p:tgtEl>
-                                          <p:spTgt spid="68"/>
-                                        </p:tgtEl>
-                                        <p:attrNameLst>
-                                          <p:attrName>ppt_y</p:attrName>
-                                        </p:attrNameLst>
-                                      </p:cBhvr>
-                                      <p:tavLst>
-                                        <p:tav tm="0">
-                                          <p:val>
-                                            <p:strVal val="#ppt_y+1"/>
-                                          </p:val>
-                                        </p:tav>
-                                        <p:tav tm="100000">
-                                          <p:val>
-                                            <p:strVal val="#ppt_y-.03"/>
-                                          </p:val>
-                                        </p:tav>
-                                      </p:tavLst>
-                                    </p:anim>
-                                    <p:anim calcmode="lin" valueType="num">
-                                      <p:cBhvr>
-                                        <p:cTn id="48" dur="100" accel="100000" fill="hold">
-                                          <p:stCondLst>
-                                            <p:cond delay="900"/>
-                                          </p:stCondLst>
-                                        </p:cTn>
-                                        <p:tgtEl>
-                                          <p:spTgt spid="68"/>
-                                        </p:tgtEl>
-                                        <p:attrNameLst>
-                                          <p:attrName>ppt_y</p:attrName>
-                                        </p:attrNameLst>
-                                      </p:cBhvr>
-                                      <p:tavLst>
-                                        <p:tav tm="0">
-                                          <p:val>
-                                            <p:strVal val="#ppt_y-.03"/>
-                                          </p:val>
-                                        </p:tav>
-                                        <p:tav tm="100000">
-                                          <p:val>
-                                            <p:strVal val="#ppt_y"/>
-                                          </p:val>
-                                        </p:tav>
-                                      </p:tavLst>
-                                    </p:anim>
                                   </p:childTnLst>
                                 </p:cTn>
                               </p:par>
                               <p:par>
-                                <p:cTn id="49" presetID="37" presetClass="entr" presetSubtype="0" fill="hold" grpId="0" nodeType="withEffect">
+                                <p:cTn id="40" presetID="22" presetClass="entr" presetSubtype="4" fill="hold" grpId="0" nodeType="withEffect">
                                   <p:stCondLst>
                                     <p:cond delay="0"/>
                                   </p:stCondLst>
                                   <p:childTnLst>
                                     <p:set>
                                       <p:cBhvr>
-                                        <p:cTn id="50" dur="1" fill="hold">
+                                        <p:cTn id="41" dur="1" fill="hold">
                                           <p:stCondLst>
                                             <p:cond delay="0"/>
                                           </p:stCondLst>
@@ -33169,87 +32950,14 @@
                                         <p:strVal val="visible"/>
                                       </p:to>
                                     </p:set>
-                                    <p:animEffect transition="in" filter="fade">
+                                    <p:animEffect transition="in" filter="wipe(down)">
                                       <p:cBhvr>
-                                        <p:cTn id="51" dur="1000"/>
+                                        <p:cTn id="42" dur="500"/>
                                         <p:tgtEl>
                                           <p:spTgt spid="44"/>
                                         </p:tgtEl>
                                       </p:cBhvr>
                                     </p:animEffect>
-                                    <p:anim calcmode="lin" valueType="num">
-                                      <p:cBhvr>
-                                        <p:cTn id="52" dur="1000" fill="hold"/>
-                                        <p:tgtEl>
-                                          <p:spTgt spid="44"/>
-                                        </p:tgtEl>
-                                        <p:attrNameLst>
-                                          <p:attrName>ppt_x</p:attrName>
-                                        </p:attrNameLst>
-                                      </p:cBhvr>
-                                      <p:tavLst>
-                                        <p:tav tm="0">
-                                          <p:val>
-                                            <p:strVal val="#ppt_x"/>
-                                          </p:val>
-                                        </p:tav>
-                                        <p:tav tm="100000">
-                                          <p:val>
-                                            <p:strVal val="#ppt_x"/>
-                                          </p:val>
-                                        </p:tav>
-                                      </p:tavLst>
-                                    </p:anim>
-                                    <p:anim calcmode="lin" valueType="num">
-                                      <p:cBhvr>
-                                        <p:cTn id="53" dur="900" decel="100000" fill="hold"/>
-                                        <p:tgtEl>
-                                          <p:spTgt spid="44"/>
-                                        </p:tgtEl>
-                                        <p:attrNameLst>
-                                          <p:attrName>ppt_y</p:attrName>
-                                        </p:attrNameLst>
-                                      </p:cBhvr>
-                                      <p:tavLst>
-                                        <p:tav tm="0">
-                                          <p:val>
-                                            <p:strVal val="#ppt_y+1"/>
-                                          </p:val>
-                                        </p:tav>
-                                        <p:tav tm="100000">
-                                          <p:val>
-                                            <p:strVal val="#ppt_y-.03"/>
-                                          </p:val>
-                                        </p:tav>
-                                      </p:tavLst>
-                                    </p:anim>
-                                    <p:anim calcmode="lin" valueType="num">
-                                      <p:cBhvr>
-                                        <p:cTn id="54" dur="100" accel="100000" fill="hold">
-                                          <p:stCondLst>
-                                            <p:cond delay="900"/>
-                                          </p:stCondLst>
-                                        </p:cTn>
-                                        <p:tgtEl>
-                                          <p:spTgt spid="44"/>
-                                        </p:tgtEl>
-                                        <p:attrNameLst>
-                                          <p:attrName>ppt_y</p:attrName>
-                                        </p:attrNameLst>
-                                      </p:cBhvr>
-                                      <p:tavLst>
-                                        <p:tav tm="0">
-                                          <p:val>
-                                            <p:strVal val="#ppt_y-.03"/>
-                                          </p:val>
-                                        </p:tav>
-                                        <p:tav tm="100000">
-                                          <p:val>
-                                            <p:strVal val="#ppt_y"/>
-                                          </p:val>
-                                        </p:tav>
-                                      </p:tavLst>
-                                    </p:anim>
                                   </p:childTnLst>
                                 </p:cTn>
                               </p:par>
@@ -33260,26 +32968,26 @@
                     </p:cTn>
                   </p:par>
                   <p:par>
-                    <p:cTn id="55" fill="hold">
+                    <p:cTn id="43" fill="hold">
                       <p:stCondLst>
                         <p:cond delay="indefinite"/>
                       </p:stCondLst>
                       <p:childTnLst>
                         <p:par>
-                          <p:cTn id="56" fill="hold">
+                          <p:cTn id="44" fill="hold">
                             <p:stCondLst>
                               <p:cond delay="0"/>
                             </p:stCondLst>
                             <p:childTnLst>
                               <p:par>
-                                <p:cTn id="57" presetID="22" presetClass="entr" presetSubtype="8" fill="hold" nodeType="clickEffect">
+                                <p:cTn id="45" presetID="22" presetClass="entr" presetSubtype="8" fill="hold" nodeType="clickEffect">
                                   <p:stCondLst>
                                     <p:cond delay="0"/>
                                   </p:stCondLst>
                                   <p:childTnLst>
                                     <p:set>
                                       <p:cBhvr>
-                                        <p:cTn id="58" dur="1" fill="hold">
+                                        <p:cTn id="46" dur="1" fill="hold">
                                           <p:stCondLst>
                                             <p:cond delay="0"/>
                                           </p:stCondLst>
@@ -33297,7 +33005,7 @@
                                     </p:set>
                                     <p:animEffect transition="in" filter="wipe(left)">
                                       <p:cBhvr>
-                                        <p:cTn id="59" dur="500"/>
+                                        <p:cTn id="47" dur="500"/>
                                         <p:tgtEl>
                                           <p:spTgt spid="69"/>
                                         </p:tgtEl>
@@ -33307,14 +33015,14 @@
                                 </p:cTn>
                               </p:par>
                               <p:par>
-                                <p:cTn id="60" presetID="3" presetClass="exit" presetSubtype="10" fill="hold" nodeType="withEffect">
+                                <p:cTn id="48" presetID="3" presetClass="exit" presetSubtype="10" fill="hold" nodeType="withEffect">
                                   <p:stCondLst>
                                     <p:cond delay="0"/>
                                   </p:stCondLst>
                                   <p:childTnLst>
                                     <p:animEffect transition="out" filter="blinds(horizontal)">
                                       <p:cBhvr>
-                                        <p:cTn id="61" dur="500"/>
+                                        <p:cTn id="49" dur="500"/>
                                         <p:tgtEl>
                                           <p:spTgt spid="65"/>
                                         </p:tgtEl>
@@ -33322,7 +33030,7 @@
                                     </p:animEffect>
                                     <p:set>
                                       <p:cBhvr>
-                                        <p:cTn id="62" dur="1" fill="hold">
+                                        <p:cTn id="50" dur="1" fill="hold">
                                           <p:stCondLst>
                                             <p:cond delay="499"/>
                                           </p:stCondLst>
@@ -33348,26 +33056,26 @@
                     </p:cTn>
                   </p:par>
                   <p:par>
-                    <p:cTn id="63" fill="hold">
+                    <p:cTn id="51" fill="hold">
                       <p:stCondLst>
                         <p:cond delay="indefinite"/>
                       </p:stCondLst>
                       <p:childTnLst>
                         <p:par>
-                          <p:cTn id="64" fill="hold">
+                          <p:cTn id="52" fill="hold">
                             <p:stCondLst>
                               <p:cond delay="0"/>
                             </p:stCondLst>
                             <p:childTnLst>
                               <p:par>
-                                <p:cTn id="65" presetID="3" presetClass="exit" presetSubtype="10" fill="hold" nodeType="clickEffect">
+                                <p:cTn id="53" presetID="22" presetClass="exit" presetSubtype="1" fill="hold" nodeType="clickEffect">
                                   <p:stCondLst>
                                     <p:cond delay="0"/>
                                   </p:stCondLst>
                                   <p:childTnLst>
-                                    <p:animEffect transition="out" filter="blinds(horizontal)">
+                                    <p:animEffect transition="out" filter="wipe(up)">
                                       <p:cBhvr>
-                                        <p:cTn id="66" dur="500"/>
+                                        <p:cTn id="54" dur="500"/>
                                         <p:tgtEl>
                                           <p:spTgt spid="68"/>
                                         </p:tgtEl>
@@ -33375,7 +33083,7 @@
                                     </p:animEffect>
                                     <p:set>
                                       <p:cBhvr>
-                                        <p:cTn id="67" dur="1" fill="hold">
+                                        <p:cTn id="55" dur="1" fill="hold">
                                           <p:stCondLst>
                                             <p:cond delay="499"/>
                                           </p:stCondLst>
@@ -33395,14 +33103,14 @@
                                 </p:cTn>
                               </p:par>
                               <p:par>
-                                <p:cTn id="68" presetID="3" presetClass="exit" presetSubtype="10" fill="hold" grpId="1" nodeType="withEffect">
+                                <p:cTn id="56" presetID="3" presetClass="exit" presetSubtype="10" fill="hold" grpId="1" nodeType="withEffect">
                                   <p:stCondLst>
                                     <p:cond delay="0"/>
                                   </p:stCondLst>
                                   <p:childTnLst>
                                     <p:animEffect transition="out" filter="blinds(horizontal)">
                                       <p:cBhvr>
-                                        <p:cTn id="69" dur="500"/>
+                                        <p:cTn id="57" dur="500"/>
                                         <p:tgtEl>
                                           <p:spTgt spid="44"/>
                                         </p:tgtEl>
@@ -33410,7 +33118,7 @@
                                     </p:animEffect>
                                     <p:set>
                                       <p:cBhvr>
-                                        <p:cTn id="70" dur="1" fill="hold">
+                                        <p:cTn id="58" dur="1" fill="hold">
                                           <p:stCondLst>
                                             <p:cond delay="499"/>
                                           </p:stCondLst>
@@ -33430,14 +33138,14 @@
                                 </p:cTn>
                               </p:par>
                               <p:par>
-                                <p:cTn id="71" presetID="3" presetClass="exit" presetSubtype="10" fill="hold" nodeType="withEffect">
+                                <p:cTn id="59" presetID="3" presetClass="exit" presetSubtype="10" fill="hold" nodeType="withEffect">
                                   <p:stCondLst>
                                     <p:cond delay="0"/>
                                   </p:stCondLst>
                                   <p:childTnLst>
                                     <p:animEffect transition="out" filter="blinds(horizontal)">
                                       <p:cBhvr>
-                                        <p:cTn id="72" dur="500"/>
+                                        <p:cTn id="60" dur="500"/>
                                         <p:tgtEl>
                                           <p:spTgt spid="69"/>
                                         </p:tgtEl>
@@ -33445,7 +33153,7 @@
                                     </p:animEffect>
                                     <p:set>
                                       <p:cBhvr>
-                                        <p:cTn id="73" dur="1" fill="hold">
+                                        <p:cTn id="61" dur="1" fill="hold">
                                           <p:stCondLst>
                                             <p:cond delay="499"/>
                                           </p:stCondLst>
@@ -33465,14 +33173,14 @@
                                 </p:cTn>
                               </p:par>
                               <p:par>
-                                <p:cTn id="74" presetID="1" presetClass="entr" presetSubtype="0" fill="hold" nodeType="withEffect">
+                                <p:cTn id="62" presetID="1" presetClass="entr" presetSubtype="0" fill="hold" nodeType="withEffect">
                                   <p:stCondLst>
                                     <p:cond delay="0"/>
                                   </p:stCondLst>
                                   <p:childTnLst>
                                     <p:set>
                                       <p:cBhvr>
-                                        <p:cTn id="75" dur="1" fill="hold">
+                                        <p:cTn id="63" dur="1" fill="hold">
                                           <p:stCondLst>
                                             <p:cond delay="0"/>
                                           </p:stCondLst>
@@ -33498,26 +33206,26 @@
                     </p:cTn>
                   </p:par>
                   <p:par>
-                    <p:cTn id="76" fill="hold">
+                    <p:cTn id="64" fill="hold">
                       <p:stCondLst>
                         <p:cond delay="indefinite"/>
                       </p:stCondLst>
                       <p:childTnLst>
                         <p:par>
-                          <p:cTn id="77" fill="hold">
+                          <p:cTn id="65" fill="hold">
                             <p:stCondLst>
                               <p:cond delay="0"/>
                             </p:stCondLst>
                             <p:childTnLst>
                               <p:par>
-                                <p:cTn id="78" presetID="37" presetClass="entr" presetSubtype="0" fill="hold" nodeType="clickEffect">
+                                <p:cTn id="66" presetID="22" presetClass="entr" presetSubtype="4" fill="hold" nodeType="clickEffect">
                                   <p:stCondLst>
                                     <p:cond delay="0"/>
                                   </p:stCondLst>
                                   <p:childTnLst>
                                     <p:set>
                                       <p:cBhvr>
-                                        <p:cTn id="79" dur="1" fill="hold">
+                                        <p:cTn id="67" dur="1" fill="hold">
                                           <p:stCondLst>
                                             <p:cond delay="0"/>
                                           </p:stCondLst>
@@ -33533,99 +33241,26 @@
                                         <p:strVal val="visible"/>
                                       </p:to>
                                     </p:set>
-                                    <p:animEffect transition="in" filter="fade">
+                                    <p:animEffect transition="in" filter="wipe(down)">
                                       <p:cBhvr>
-                                        <p:cTn id="80" dur="1000"/>
+                                        <p:cTn id="68" dur="500"/>
                                         <p:tgtEl>
                                           <p:spTgt spid="76"/>
                                         </p:tgtEl>
                                       </p:cBhvr>
                                     </p:animEffect>
-                                    <p:anim calcmode="lin" valueType="num">
-                                      <p:cBhvr>
-                                        <p:cTn id="81" dur="1000" fill="hold"/>
-                                        <p:tgtEl>
-                                          <p:spTgt spid="76"/>
-                                        </p:tgtEl>
-                                        <p:attrNameLst>
-                                          <p:attrName>ppt_x</p:attrName>
-                                        </p:attrNameLst>
-                                      </p:cBhvr>
-                                      <p:tavLst>
-                                        <p:tav tm="0">
-                                          <p:val>
-                                            <p:strVal val="#ppt_x"/>
-                                          </p:val>
-                                        </p:tav>
-                                        <p:tav tm="100000">
-                                          <p:val>
-                                            <p:strVal val="#ppt_x"/>
-                                          </p:val>
-                                        </p:tav>
-                                      </p:tavLst>
-                                    </p:anim>
-                                    <p:anim calcmode="lin" valueType="num">
-                                      <p:cBhvr>
-                                        <p:cTn id="82" dur="900" decel="100000" fill="hold"/>
-                                        <p:tgtEl>
-                                          <p:spTgt spid="76"/>
-                                        </p:tgtEl>
-                                        <p:attrNameLst>
-                                          <p:attrName>ppt_y</p:attrName>
-                                        </p:attrNameLst>
-                                      </p:cBhvr>
-                                      <p:tavLst>
-                                        <p:tav tm="0">
-                                          <p:val>
-                                            <p:strVal val="#ppt_y+1"/>
-                                          </p:val>
-                                        </p:tav>
-                                        <p:tav tm="100000">
-                                          <p:val>
-                                            <p:strVal val="#ppt_y-.03"/>
-                                          </p:val>
-                                        </p:tav>
-                                      </p:tavLst>
-                                    </p:anim>
-                                    <p:anim calcmode="lin" valueType="num">
-                                      <p:cBhvr>
-                                        <p:cTn id="83" dur="100" accel="100000" fill="hold">
-                                          <p:stCondLst>
-                                            <p:cond delay="900"/>
-                                          </p:stCondLst>
-                                        </p:cTn>
-                                        <p:tgtEl>
-                                          <p:spTgt spid="76"/>
-                                        </p:tgtEl>
-                                        <p:attrNameLst>
-                                          <p:attrName>ppt_y</p:attrName>
-                                        </p:attrNameLst>
-                                      </p:cBhvr>
-                                      <p:tavLst>
-                                        <p:tav tm="0">
-                                          <p:val>
-                                            <p:strVal val="#ppt_y-.03"/>
-                                          </p:val>
-                                        </p:tav>
-                                        <p:tav tm="100000">
-                                          <p:val>
-                                            <p:strVal val="#ppt_y"/>
-                                          </p:val>
-                                        </p:tav>
-                                      </p:tavLst>
-                                    </p:anim>
                                   </p:childTnLst>
                                 </p:cTn>
                               </p:par>
                               <p:par>
-                                <p:cTn id="84" presetID="37" presetClass="entr" presetSubtype="0" fill="hold" grpId="0" nodeType="withEffect">
+                                <p:cTn id="69" presetID="22" presetClass="entr" presetSubtype="4" fill="hold" grpId="0" nodeType="withEffect">
                                   <p:stCondLst>
                                     <p:cond delay="0"/>
                                   </p:stCondLst>
                                   <p:childTnLst>
                                     <p:set>
                                       <p:cBhvr>
-                                        <p:cTn id="85" dur="1" fill="hold">
+                                        <p:cTn id="70" dur="1" fill="hold">
                                           <p:stCondLst>
                                             <p:cond delay="0"/>
                                           </p:stCondLst>
@@ -33641,87 +33276,14 @@
                                         <p:strVal val="visible"/>
                                       </p:to>
                                     </p:set>
-                                    <p:animEffect transition="in" filter="fade">
+                                    <p:animEffect transition="in" filter="wipe(down)">
                                       <p:cBhvr>
-                                        <p:cTn id="86" dur="1000"/>
+                                        <p:cTn id="71" dur="500"/>
                                         <p:tgtEl>
                                           <p:spTgt spid="77"/>
                                         </p:tgtEl>
                                       </p:cBhvr>
                                     </p:animEffect>
-                                    <p:anim calcmode="lin" valueType="num">
-                                      <p:cBhvr>
-                                        <p:cTn id="87" dur="1000" fill="hold"/>
-                                        <p:tgtEl>
-                                          <p:spTgt spid="77"/>
-                                        </p:tgtEl>
-                                        <p:attrNameLst>
-                                          <p:attrName>ppt_x</p:attrName>
-                                        </p:attrNameLst>
-                                      </p:cBhvr>
-                                      <p:tavLst>
-                                        <p:tav tm="0">
-                                          <p:val>
-                                            <p:strVal val="#ppt_x"/>
-                                          </p:val>
-                                        </p:tav>
-                                        <p:tav tm="100000">
-                                          <p:val>
-                                            <p:strVal val="#ppt_x"/>
-                                          </p:val>
-                                        </p:tav>
-                                      </p:tavLst>
-                                    </p:anim>
-                                    <p:anim calcmode="lin" valueType="num">
-                                      <p:cBhvr>
-                                        <p:cTn id="88" dur="900" decel="100000" fill="hold"/>
-                                        <p:tgtEl>
-                                          <p:spTgt spid="77"/>
-                                        </p:tgtEl>
-                                        <p:attrNameLst>
-                                          <p:attrName>ppt_y</p:attrName>
-                                        </p:attrNameLst>
-                                      </p:cBhvr>
-                                      <p:tavLst>
-                                        <p:tav tm="0">
-                                          <p:val>
-                                            <p:strVal val="#ppt_y+1"/>
-                                          </p:val>
-                                        </p:tav>
-                                        <p:tav tm="100000">
-                                          <p:val>
-                                            <p:strVal val="#ppt_y-.03"/>
-                                          </p:val>
-                                        </p:tav>
-                                      </p:tavLst>
-                                    </p:anim>
-                                    <p:anim calcmode="lin" valueType="num">
-                                      <p:cBhvr>
-                                        <p:cTn id="89" dur="100" accel="100000" fill="hold">
-                                          <p:stCondLst>
-                                            <p:cond delay="900"/>
-                                          </p:stCondLst>
-                                        </p:cTn>
-                                        <p:tgtEl>
-                                          <p:spTgt spid="77"/>
-                                        </p:tgtEl>
-                                        <p:attrNameLst>
-                                          <p:attrName>ppt_y</p:attrName>
-                                        </p:attrNameLst>
-                                      </p:cBhvr>
-                                      <p:tavLst>
-                                        <p:tav tm="0">
-                                          <p:val>
-                                            <p:strVal val="#ppt_y-.03"/>
-                                          </p:val>
-                                        </p:tav>
-                                        <p:tav tm="100000">
-                                          <p:val>
-                                            <p:strVal val="#ppt_y"/>
-                                          </p:val>
-                                        </p:tav>
-                                      </p:tavLst>
-                                    </p:anim>
                                   </p:childTnLst>
                                 </p:cTn>
                               </p:par>
@@ -33732,26 +33294,26 @@
                     </p:cTn>
                   </p:par>
                   <p:par>
-                    <p:cTn id="90" fill="hold">
+                    <p:cTn id="72" fill="hold">
                       <p:stCondLst>
                         <p:cond delay="indefinite"/>
                       </p:stCondLst>
                       <p:childTnLst>
                         <p:par>
-                          <p:cTn id="91" fill="hold">
+                          <p:cTn id="73" fill="hold">
                             <p:stCondLst>
                               <p:cond delay="0"/>
                             </p:stCondLst>
                             <p:childTnLst>
                               <p:par>
-                                <p:cTn id="92" presetID="3" presetClass="entr" presetSubtype="10" fill="hold" grpId="0" nodeType="clickEffect">
+                                <p:cTn id="74" presetID="3" presetClass="entr" presetSubtype="10" fill="hold" grpId="0" nodeType="clickEffect">
                                   <p:stCondLst>
                                     <p:cond delay="0"/>
                                   </p:stCondLst>
                                   <p:childTnLst>
                                     <p:set>
                                       <p:cBhvr>
-                                        <p:cTn id="93" dur="1" fill="hold">
+                                        <p:cTn id="75" dur="1" fill="hold">
                                           <p:stCondLst>
                                             <p:cond delay="0"/>
                                           </p:stCondLst>
@@ -33769,7 +33331,7 @@
                                     </p:set>
                                     <p:animEffect transition="in" filter="blinds(horizontal)">
                                       <p:cBhvr>
-                                        <p:cTn id="94" dur="500"/>
+                                        <p:cTn id="76" dur="500"/>
                                         <p:tgtEl>
                                           <p:spTgt spid="75"/>
                                         </p:tgtEl>
@@ -33785,26 +33347,26 @@
                     </p:cTn>
                   </p:par>
                   <p:par>
-                    <p:cTn id="95" fill="hold">
+                    <p:cTn id="77" fill="hold">
                       <p:stCondLst>
                         <p:cond delay="indefinite"/>
                       </p:stCondLst>
                       <p:childTnLst>
                         <p:par>
-                          <p:cTn id="96" fill="hold">
+                          <p:cTn id="78" fill="hold">
                             <p:stCondLst>
                               <p:cond delay="0"/>
                             </p:stCondLst>
                             <p:childTnLst>
                               <p:par>
-                                <p:cTn id="97" presetID="3" presetClass="entr" presetSubtype="10" fill="hold" grpId="0" nodeType="clickEffect">
+                                <p:cTn id="79" presetID="3" presetClass="entr" presetSubtype="10" fill="hold" grpId="0" nodeType="clickEffect">
                                   <p:stCondLst>
                                     <p:cond delay="0"/>
                                   </p:stCondLst>
                                   <p:childTnLst>
                                     <p:set>
                                       <p:cBhvr>
-                                        <p:cTn id="98" dur="1" fill="hold">
+                                        <p:cTn id="80" dur="1" fill="hold">
                                           <p:stCondLst>
                                             <p:cond delay="0"/>
                                           </p:stCondLst>
@@ -33822,7 +33384,7 @@
                                     </p:set>
                                     <p:animEffect transition="in" filter="blinds(horizontal)">
                                       <p:cBhvr>
-                                        <p:cTn id="99" dur="500"/>
+                                        <p:cTn id="81" dur="500"/>
                                         <p:tgtEl>
                                           <p:spTgt spid="78"/>
                                         </p:tgtEl>

</xml_diff>